<commit_message>
Add roadmap slide, fix slide order, server URLs, README roadmap
- Slide 20: Roadmap (Keycloak, VND parsing, GPU cluster, scaling)
- Slide 21: Спасибо (moved after roadmap)
- All URLs: localhost → 89.207.255.254
- README: roadmap section with current vs target tables
</commit_message>
<xml_diff>
--- a/KMG_HR_AI_Presentation.pptx
+++ b/KMG_HR_AI_Presentation.pptx
@@ -35,6 +35,7 @@
     <p:sldId id="273" r:id="rId30"/>
     <p:sldId id="274" r:id="rId31"/>
     <p:sldId id="275" r:id="rId32"/>
+    <p:sldId id="276" r:id="rId33"/>
   </p:sldIdLst>
   <p:sldSz cx="12188825" cy="6858000"/>
   <p:notesSz cx="7559675" cy="10691813"/>
@@ -172,7 +173,7 @@
         <p:txBody>
           <a:bodyPr/>
           <a:p>
-            <a:fld id="{60335914-CA49-4CB8-95E8-974E2084ECCB}" type="slidenum">
+            <a:fld id="{7EB4410C-A1D4-4AE5-AC0C-3B165A53350F}" type="slidenum">
               <a:t>&lt;#&gt;</a:t>
             </a:fld>
           </a:p>
@@ -255,7 +256,7 @@
         <p:txBody>
           <a:bodyPr/>
           <a:p>
-            <a:fld id="{B6C45EAF-3F24-476C-AD26-47BDF0C43757}" type="slidenum">
+            <a:fld id="{C6476016-0599-4ECB-AF71-3EA19216835D}" type="slidenum">
               <a:t>&lt;#&gt;</a:t>
             </a:fld>
           </a:p>
@@ -338,7 +339,7 @@
         <p:txBody>
           <a:bodyPr/>
           <a:p>
-            <a:fld id="{305BCA4C-BB20-4586-BB2C-5FFD2E7EC325}" type="slidenum">
+            <a:fld id="{3464F71B-DF94-4ED9-A56B-2FD9E8C74140}" type="slidenum">
               <a:t>&lt;#&gt;</a:t>
             </a:fld>
           </a:p>
@@ -421,7 +422,7 @@
         <p:txBody>
           <a:bodyPr/>
           <a:p>
-            <a:fld id="{87A80C1E-A076-4DF1-B319-AE221942E47B}" type="slidenum">
+            <a:fld id="{D645B2AF-AC1B-443E-A5B8-59EBE4BDC2D3}" type="slidenum">
               <a:t>&lt;#&gt;</a:t>
             </a:fld>
           </a:p>
@@ -504,7 +505,7 @@
         <p:txBody>
           <a:bodyPr/>
           <a:p>
-            <a:fld id="{6E78837E-BC78-4FC3-A1AB-2DDA51BC0689}" type="slidenum">
+            <a:fld id="{05DC4CFD-FE87-4FCF-A46C-DEEF2C2690B3}" type="slidenum">
               <a:t>&lt;#&gt;</a:t>
             </a:fld>
           </a:p>
@@ -670,7 +671,7 @@
         <p:txBody>
           <a:bodyPr/>
           <a:p>
-            <a:fld id="{D0DA220A-0D1C-412D-B5FA-27D1C60B4FDE}" type="slidenum">
+            <a:fld id="{61BC701A-7172-46FB-AD7B-BF83EA650216}" type="slidenum">
               <a:t>&lt;#&gt;</a:t>
             </a:fld>
           </a:p>
@@ -753,7 +754,7 @@
         <p:txBody>
           <a:bodyPr/>
           <a:p>
-            <a:fld id="{6E81C418-34FD-4C54-8C8B-54639FFE75ED}" type="slidenum">
+            <a:fld id="{E1F5C319-8C9C-4BAC-BE46-7F8B0CBEAF58}" type="slidenum">
               <a:t>&lt;#&gt;</a:t>
             </a:fld>
           </a:p>
@@ -962,7 +963,7 @@
         <p:txBody>
           <a:bodyPr/>
           <a:p>
-            <a:fld id="{3246BD39-DB61-4A4B-B0DF-CE882646E5D0}" type="slidenum">
+            <a:fld id="{3F636BAB-B28F-43B4-AFA0-E2475585C6B1}" type="slidenum">
               <a:t>&lt;#&gt;</a:t>
             </a:fld>
           </a:p>
@@ -1045,7 +1046,7 @@
         <p:txBody>
           <a:bodyPr/>
           <a:p>
-            <a:fld id="{DE6408C5-EB7E-4478-91A2-8900D3C51955}" type="slidenum">
+            <a:fld id="{CF454358-C7FA-4954-B43E-556FE6C94724}" type="slidenum">
               <a:t>&lt;#&gt;</a:t>
             </a:fld>
           </a:p>
@@ -1168,7 +1169,7 @@
         <p:txBody>
           <a:bodyPr/>
           <a:p>
-            <a:fld id="{185A48DB-E9F6-46D1-9ABD-A0687ED5F8F5}" type="slidenum">
+            <a:fld id="{E69E5165-FDBC-47FE-86FB-9CEF92150EBF}" type="slidenum">
               <a:t>&lt;#&gt;</a:t>
             </a:fld>
           </a:p>
@@ -1251,7 +1252,7 @@
         <p:txBody>
           <a:bodyPr/>
           <a:p>
-            <a:fld id="{E32CF00D-65EE-4529-AC53-43676DA5EC0A}" type="slidenum">
+            <a:fld id="{5038905A-E606-485A-B02E-577F51702D7D}" type="slidenum">
               <a:t>&lt;#&gt;</a:t>
             </a:fld>
           </a:p>
@@ -1348,7 +1349,232 @@
                 </a:solidFill>
                 <a:latin typeface="Calibri"/>
               </a:rPr>
-              <a:t>Click to edit Master title style</a:t>
+              <a:t>C</a:t>
+            </a:r>
+            <a:r>
+              <a:rPr b="0" lang="en-US" sz="4400" spc="-1" strike="noStrike">
+                <a:solidFill>
+                  <a:schemeClr val="dk1"/>
+                </a:solidFill>
+                <a:latin typeface="Calibri"/>
+              </a:rPr>
+              <a:t>li</a:t>
+            </a:r>
+            <a:r>
+              <a:rPr b="0" lang="en-US" sz="4400" spc="-1" strike="noStrike">
+                <a:solidFill>
+                  <a:schemeClr val="dk1"/>
+                </a:solidFill>
+                <a:latin typeface="Calibri"/>
+              </a:rPr>
+              <a:t>c</a:t>
+            </a:r>
+            <a:r>
+              <a:rPr b="0" lang="en-US" sz="4400" spc="-1" strike="noStrike">
+                <a:solidFill>
+                  <a:schemeClr val="dk1"/>
+                </a:solidFill>
+                <a:latin typeface="Calibri"/>
+              </a:rPr>
+              <a:t>k </a:t>
+            </a:r>
+            <a:r>
+              <a:rPr b="0" lang="en-US" sz="4400" spc="-1" strike="noStrike">
+                <a:solidFill>
+                  <a:schemeClr val="dk1"/>
+                </a:solidFill>
+                <a:latin typeface="Calibri"/>
+              </a:rPr>
+              <a:t>t</a:t>
+            </a:r>
+            <a:r>
+              <a:rPr b="0" lang="en-US" sz="4400" spc="-1" strike="noStrike">
+                <a:solidFill>
+                  <a:schemeClr val="dk1"/>
+                </a:solidFill>
+                <a:latin typeface="Calibri"/>
+              </a:rPr>
+              <a:t>o </a:t>
+            </a:r>
+            <a:r>
+              <a:rPr b="0" lang="en-US" sz="4400" spc="-1" strike="noStrike">
+                <a:solidFill>
+                  <a:schemeClr val="dk1"/>
+                </a:solidFill>
+                <a:latin typeface="Calibri"/>
+              </a:rPr>
+              <a:t>e</a:t>
+            </a:r>
+            <a:r>
+              <a:rPr b="0" lang="en-US" sz="4400" spc="-1" strike="noStrike">
+                <a:solidFill>
+                  <a:schemeClr val="dk1"/>
+                </a:solidFill>
+                <a:latin typeface="Calibri"/>
+              </a:rPr>
+              <a:t>d</a:t>
+            </a:r>
+            <a:r>
+              <a:rPr b="0" lang="en-US" sz="4400" spc="-1" strike="noStrike">
+                <a:solidFill>
+                  <a:schemeClr val="dk1"/>
+                </a:solidFill>
+                <a:latin typeface="Calibri"/>
+              </a:rPr>
+              <a:t>i</a:t>
+            </a:r>
+            <a:r>
+              <a:rPr b="0" lang="en-US" sz="4400" spc="-1" strike="noStrike">
+                <a:solidFill>
+                  <a:schemeClr val="dk1"/>
+                </a:solidFill>
+                <a:latin typeface="Calibri"/>
+              </a:rPr>
+              <a:t>t </a:t>
+            </a:r>
+            <a:r>
+              <a:rPr b="0" lang="en-US" sz="4400" spc="-1" strike="noStrike">
+                <a:solidFill>
+                  <a:schemeClr val="dk1"/>
+                </a:solidFill>
+                <a:latin typeface="Calibri"/>
+              </a:rPr>
+              <a:t>M</a:t>
+            </a:r>
+            <a:r>
+              <a:rPr b="0" lang="en-US" sz="4400" spc="-1" strike="noStrike">
+                <a:solidFill>
+                  <a:schemeClr val="dk1"/>
+                </a:solidFill>
+                <a:latin typeface="Calibri"/>
+              </a:rPr>
+              <a:t>a</a:t>
+            </a:r>
+            <a:r>
+              <a:rPr b="0" lang="en-US" sz="4400" spc="-1" strike="noStrike">
+                <a:solidFill>
+                  <a:schemeClr val="dk1"/>
+                </a:solidFill>
+                <a:latin typeface="Calibri"/>
+              </a:rPr>
+              <a:t>s</a:t>
+            </a:r>
+            <a:r>
+              <a:rPr b="0" lang="en-US" sz="4400" spc="-1" strike="noStrike">
+                <a:solidFill>
+                  <a:schemeClr val="dk1"/>
+                </a:solidFill>
+                <a:latin typeface="Calibri"/>
+              </a:rPr>
+              <a:t>t</a:t>
+            </a:r>
+            <a:r>
+              <a:rPr b="0" lang="en-US" sz="4400" spc="-1" strike="noStrike">
+                <a:solidFill>
+                  <a:schemeClr val="dk1"/>
+                </a:solidFill>
+                <a:latin typeface="Calibri"/>
+              </a:rPr>
+              <a:t>e</a:t>
+            </a:r>
+            <a:r>
+              <a:rPr b="0" lang="en-US" sz="4400" spc="-1" strike="noStrike">
+                <a:solidFill>
+                  <a:schemeClr val="dk1"/>
+                </a:solidFill>
+                <a:latin typeface="Calibri"/>
+              </a:rPr>
+              <a:t>r </a:t>
+            </a:r>
+            <a:r>
+              <a:rPr b="0" lang="en-US" sz="4400" spc="-1" strike="noStrike">
+                <a:solidFill>
+                  <a:schemeClr val="dk1"/>
+                </a:solidFill>
+                <a:latin typeface="Calibri"/>
+              </a:rPr>
+              <a:t>t</a:t>
+            </a:r>
+            <a:r>
+              <a:rPr b="0" lang="en-US" sz="4400" spc="-1" strike="noStrike">
+                <a:solidFill>
+                  <a:schemeClr val="dk1"/>
+                </a:solidFill>
+                <a:latin typeface="Calibri"/>
+              </a:rPr>
+              <a:t>i</a:t>
+            </a:r>
+            <a:r>
+              <a:rPr b="0" lang="en-US" sz="4400" spc="-1" strike="noStrike">
+                <a:solidFill>
+                  <a:schemeClr val="dk1"/>
+                </a:solidFill>
+                <a:latin typeface="Calibri"/>
+              </a:rPr>
+              <a:t>t</a:t>
+            </a:r>
+            <a:r>
+              <a:rPr b="0" lang="en-US" sz="4400" spc="-1" strike="noStrike">
+                <a:solidFill>
+                  <a:schemeClr val="dk1"/>
+                </a:solidFill>
+                <a:latin typeface="Calibri"/>
+              </a:rPr>
+              <a:t>l</a:t>
+            </a:r>
+            <a:r>
+              <a:rPr b="0" lang="en-US" sz="4400" spc="-1" strike="noStrike">
+                <a:solidFill>
+                  <a:schemeClr val="dk1"/>
+                </a:solidFill>
+                <a:latin typeface="Calibri"/>
+              </a:rPr>
+              <a:t>e </a:t>
+            </a:r>
+            <a:r>
+              <a:rPr b="0" lang="en-US" sz="4400" spc="-1" strike="noStrike">
+                <a:solidFill>
+                  <a:schemeClr val="dk1"/>
+                </a:solidFill>
+                <a:latin typeface="Calibri"/>
+              </a:rPr>
+              <a:t>s</a:t>
+            </a:r>
+            <a:r>
+              <a:rPr b="0" lang="en-US" sz="4400" spc="-1" strike="noStrike">
+                <a:solidFill>
+                  <a:schemeClr val="dk1"/>
+                </a:solidFill>
+                <a:latin typeface="Calibri"/>
+              </a:rPr>
+              <a:t>t</a:t>
+            </a:r>
+            <a:r>
+              <a:rPr b="0" lang="en-US" sz="4400" spc="-1" strike="noStrike">
+                <a:solidFill>
+                  <a:schemeClr val="dk1"/>
+                </a:solidFill>
+                <a:latin typeface="Calibri"/>
+              </a:rPr>
+              <a:t>y</a:t>
+            </a:r>
+            <a:r>
+              <a:rPr b="0" lang="en-US" sz="4400" spc="-1" strike="noStrike">
+                <a:solidFill>
+                  <a:schemeClr val="dk1"/>
+                </a:solidFill>
+                <a:latin typeface="Calibri"/>
+              </a:rPr>
+              <a:t>l</a:t>
+            </a:r>
+            <a:r>
+              <a:rPr b="0" lang="en-US" sz="4400" spc="-1" strike="noStrike">
+                <a:solidFill>
+                  <a:schemeClr val="dk1"/>
+                </a:solidFill>
+                <a:latin typeface="Calibri"/>
+              </a:rPr>
+              <a:t>e</a:t>
             </a:r>
             <a:endParaRPr b="0" lang="en-US" sz="4400" spc="-1" strike="noStrike">
               <a:solidFill>
@@ -1539,7 +1765,7 @@
               </a:lnSpc>
               <a:buNone/>
             </a:pPr>
-            <a:fld id="{D071CE9F-4635-4AB8-8DD5-99C58741A528}" type="slidenum">
+            <a:fld id="{8541B2D9-E45C-4DC4-8EA3-77EE141FAFC7}" type="slidenum">
               <a:rPr b="0" lang="en-US" sz="1200" spc="-1" strike="noStrike">
                 <a:solidFill>
                   <a:schemeClr val="dk1">
@@ -2061,7 +2287,7 @@
               </a:lnSpc>
               <a:buNone/>
             </a:pPr>
-            <a:fld id="{82301C37-503C-45BD-BBBD-D8F26DA8CB84}" type="slidenum">
+            <a:fld id="{5DF72B5A-7D58-4719-B851-7BF84A9ED76D}" type="slidenum">
               <a:rPr b="0" lang="en-US" sz="1200" spc="-1" strike="noStrike">
                 <a:solidFill>
                   <a:schemeClr val="dk1">
@@ -2629,7 +2855,7 @@
               </a:lnSpc>
               <a:buNone/>
             </a:pPr>
-            <a:fld id="{19DD0D1F-BEAE-4A2B-BAE4-7D03F7F930B9}" type="slidenum">
+            <a:fld id="{B62BED88-68B4-42A9-9999-DC3BD0B206BD}" type="slidenum">
               <a:rPr b="0" lang="en-US" sz="1200" spc="-1" strike="noStrike">
                 <a:solidFill>
                   <a:schemeClr val="dk1">
@@ -2723,7 +2949,52 @@
                 </a:solidFill>
                 <a:latin typeface="Calibri"/>
               </a:rPr>
-              <a:t>Click to edit Master title style</a:t>
+              <a:t>Click </a:t>
+            </a:r>
+            <a:r>
+              <a:rPr b="0" lang="en-US" sz="4400" spc="-1" strike="noStrike">
+                <a:solidFill>
+                  <a:schemeClr val="dk1"/>
+                </a:solidFill>
+                <a:latin typeface="Calibri"/>
+              </a:rPr>
+              <a:t>to </a:t>
+            </a:r>
+            <a:r>
+              <a:rPr b="0" lang="en-US" sz="4400" spc="-1" strike="noStrike">
+                <a:solidFill>
+                  <a:schemeClr val="dk1"/>
+                </a:solidFill>
+                <a:latin typeface="Calibri"/>
+              </a:rPr>
+              <a:t>edit </a:t>
+            </a:r>
+            <a:r>
+              <a:rPr b="0" lang="en-US" sz="4400" spc="-1" strike="noStrike">
+                <a:solidFill>
+                  <a:schemeClr val="dk1"/>
+                </a:solidFill>
+                <a:latin typeface="Calibri"/>
+              </a:rPr>
+              <a:t>Maste</a:t>
+            </a:r>
+            <a:r>
+              <a:rPr b="0" lang="en-US" sz="4400" spc="-1" strike="noStrike">
+                <a:solidFill>
+                  <a:schemeClr val="dk1"/>
+                </a:solidFill>
+                <a:latin typeface="Calibri"/>
+              </a:rPr>
+              <a:t>r title </a:t>
+            </a:r>
+            <a:r>
+              <a:rPr b="0" lang="en-US" sz="4400" spc="-1" strike="noStrike">
+                <a:solidFill>
+                  <a:schemeClr val="dk1"/>
+                </a:solidFill>
+                <a:latin typeface="Calibri"/>
+              </a:rPr>
+              <a:t>style</a:t>
             </a:r>
             <a:endParaRPr b="0" lang="en-US" sz="4400" spc="-1" strike="noStrike">
               <a:solidFill>
@@ -3093,7 +3364,7 @@
               </a:lnSpc>
               <a:buNone/>
             </a:pPr>
-            <a:fld id="{A61333BD-E8C2-41F3-8D68-E14EA5327AA3}" type="slidenum">
+            <a:fld id="{B295A1F9-3396-4520-929E-8BE0E763F2AA}" type="slidenum">
               <a:rPr b="0" lang="en-US" sz="1200" spc="-1" strike="noStrike">
                 <a:solidFill>
                   <a:schemeClr val="dk1">
@@ -3187,7 +3458,7 @@
                 </a:solidFill>
                 <a:latin typeface="Calibri"/>
               </a:rPr>
-              <a:t>C</a:t>
+              <a:t>Cl</a:t>
             </a:r>
             <a:r>
               <a:rPr b="0" lang="en-US" sz="4400" spc="-1" strike="noStrike">
@@ -3196,7 +3467,7 @@
                 </a:solidFill>
                 <a:latin typeface="Calibri"/>
               </a:rPr>
-              <a:t>l</a:t>
+              <a:t>ic</a:t>
             </a:r>
             <a:r>
               <a:rPr b="0" lang="en-US" sz="4400" spc="-1" strike="noStrike">
@@ -3205,7 +3476,7 @@
                 </a:solidFill>
                 <a:latin typeface="Calibri"/>
               </a:rPr>
-              <a:t>i</a:t>
+              <a:t>k </a:t>
             </a:r>
             <a:r>
               <a:rPr b="0" lang="en-US" sz="4400" spc="-1" strike="noStrike">
@@ -3214,7 +3485,7 @@
                 </a:solidFill>
                 <a:latin typeface="Calibri"/>
               </a:rPr>
-              <a:t>c</a:t>
+              <a:t>t</a:t>
             </a:r>
             <a:r>
               <a:rPr b="0" lang="en-US" sz="4400" spc="-1" strike="noStrike">
@@ -3223,7 +3494,7 @@
                 </a:solidFill>
                 <a:latin typeface="Calibri"/>
               </a:rPr>
-              <a:t>k</a:t>
+              <a:t>o </a:t>
             </a:r>
             <a:r>
               <a:rPr b="0" lang="en-US" sz="4400" spc="-1" strike="noStrike">
@@ -3232,7 +3503,7 @@
                 </a:solidFill>
                 <a:latin typeface="Calibri"/>
               </a:rPr>
-              <a:t> </a:t>
+              <a:t>e</a:t>
             </a:r>
             <a:r>
               <a:rPr b="0" lang="en-US" sz="4400" spc="-1" strike="noStrike">
@@ -3241,7 +3512,7 @@
                 </a:solidFill>
                 <a:latin typeface="Calibri"/>
               </a:rPr>
-              <a:t>t</a:t>
+              <a:t>di</a:t>
             </a:r>
             <a:r>
               <a:rPr b="0" lang="en-US" sz="4400" spc="-1" strike="noStrike">
@@ -3250,7 +3521,7 @@
                 </a:solidFill>
                 <a:latin typeface="Calibri"/>
               </a:rPr>
-              <a:t>o</a:t>
+              <a:t>t </a:t>
             </a:r>
             <a:r>
               <a:rPr b="0" lang="en-US" sz="4400" spc="-1" strike="noStrike">
@@ -3259,7 +3530,7 @@
                 </a:solidFill>
                 <a:latin typeface="Calibri"/>
               </a:rPr>
-              <a:t> </a:t>
+              <a:t>M</a:t>
             </a:r>
             <a:r>
               <a:rPr b="0" lang="en-US" sz="4400" spc="-1" strike="noStrike">
@@ -3268,6 +3539,24 @@
                 </a:solidFill>
                 <a:latin typeface="Calibri"/>
               </a:rPr>
+              <a:t>a</a:t>
+            </a:r>
+            <a:r>
+              <a:rPr b="0" lang="en-US" sz="4400" spc="-1" strike="noStrike">
+                <a:solidFill>
+                  <a:schemeClr val="dk1"/>
+                </a:solidFill>
+                <a:latin typeface="Calibri"/>
+              </a:rPr>
+              <a:t>st</a:t>
+            </a:r>
+            <a:r>
+              <a:rPr b="0" lang="en-US" sz="4400" spc="-1" strike="noStrike">
+                <a:solidFill>
+                  <a:schemeClr val="dk1"/>
+                </a:solidFill>
+                <a:latin typeface="Calibri"/>
+              </a:rPr>
               <a:t>e</a:t>
             </a:r>
             <a:r>
@@ -3277,7 +3566,7 @@
                 </a:solidFill>
                 <a:latin typeface="Calibri"/>
               </a:rPr>
-              <a:t>d</a:t>
+              <a:t>r </a:t>
             </a:r>
             <a:r>
               <a:rPr b="0" lang="en-US" sz="4400" spc="-1" strike="noStrike">
@@ -3286,7 +3575,7 @@
                 </a:solidFill>
                 <a:latin typeface="Calibri"/>
               </a:rPr>
-              <a:t>i</a:t>
+              <a:t>ti</a:t>
             </a:r>
             <a:r>
               <a:rPr b="0" lang="en-US" sz="4400" spc="-1" strike="noStrike">
@@ -3295,7 +3584,7 @@
                 </a:solidFill>
                 <a:latin typeface="Calibri"/>
               </a:rPr>
-              <a:t>t </a:t>
+              <a:t>tl</a:t>
             </a:r>
             <a:r>
               <a:rPr b="0" lang="en-US" sz="4400" spc="-1" strike="noStrike">
@@ -3304,7 +3593,7 @@
                 </a:solidFill>
                 <a:latin typeface="Calibri"/>
               </a:rPr>
-              <a:t>M</a:t>
+              <a:t>e </a:t>
             </a:r>
             <a:r>
               <a:rPr b="0" lang="en-US" sz="4400" spc="-1" strike="noStrike">
@@ -3313,7 +3602,7 @@
                 </a:solidFill>
                 <a:latin typeface="Calibri"/>
               </a:rPr>
-              <a:t>a</a:t>
+              <a:t>st</a:t>
             </a:r>
             <a:r>
               <a:rPr b="0" lang="en-US" sz="4400" spc="-1" strike="noStrike">
@@ -3322,124 +3611,7 @@
                 </a:solidFill>
                 <a:latin typeface="Calibri"/>
               </a:rPr>
-              <a:t>s</a:t>
-            </a:r>
-            <a:r>
-              <a:rPr b="0" lang="en-US" sz="4400" spc="-1" strike="noStrike">
-                <a:solidFill>
-                  <a:schemeClr val="dk1"/>
-                </a:solidFill>
-                <a:latin typeface="Calibri"/>
-              </a:rPr>
-              <a:t>t</a:t>
-            </a:r>
-            <a:r>
-              <a:rPr b="0" lang="en-US" sz="4400" spc="-1" strike="noStrike">
-                <a:solidFill>
-                  <a:schemeClr val="dk1"/>
-                </a:solidFill>
-                <a:latin typeface="Calibri"/>
-              </a:rPr>
-              <a:t>e</a:t>
-            </a:r>
-            <a:r>
-              <a:rPr b="0" lang="en-US" sz="4400" spc="-1" strike="noStrike">
-                <a:solidFill>
-                  <a:schemeClr val="dk1"/>
-                </a:solidFill>
-                <a:latin typeface="Calibri"/>
-              </a:rPr>
-              <a:t>r </a:t>
-            </a:r>
-            <a:r>
-              <a:rPr b="0" lang="en-US" sz="4400" spc="-1" strike="noStrike">
-                <a:solidFill>
-                  <a:schemeClr val="dk1"/>
-                </a:solidFill>
-                <a:latin typeface="Calibri"/>
-              </a:rPr>
-              <a:t>t</a:t>
-            </a:r>
-            <a:r>
-              <a:rPr b="0" lang="en-US" sz="4400" spc="-1" strike="noStrike">
-                <a:solidFill>
-                  <a:schemeClr val="dk1"/>
-                </a:solidFill>
-                <a:latin typeface="Calibri"/>
-              </a:rPr>
-              <a:t>i</a:t>
-            </a:r>
-            <a:r>
-              <a:rPr b="0" lang="en-US" sz="4400" spc="-1" strike="noStrike">
-                <a:solidFill>
-                  <a:schemeClr val="dk1"/>
-                </a:solidFill>
-                <a:latin typeface="Calibri"/>
-              </a:rPr>
-              <a:t>t</a:t>
-            </a:r>
-            <a:r>
-              <a:rPr b="0" lang="en-US" sz="4400" spc="-1" strike="noStrike">
-                <a:solidFill>
-                  <a:schemeClr val="dk1"/>
-                </a:solidFill>
-                <a:latin typeface="Calibri"/>
-              </a:rPr>
-              <a:t>l</a:t>
-            </a:r>
-            <a:r>
-              <a:rPr b="0" lang="en-US" sz="4400" spc="-1" strike="noStrike">
-                <a:solidFill>
-                  <a:schemeClr val="dk1"/>
-                </a:solidFill>
-                <a:latin typeface="Calibri"/>
-              </a:rPr>
-              <a:t>e</a:t>
-            </a:r>
-            <a:r>
-              <a:rPr b="0" lang="en-US" sz="4400" spc="-1" strike="noStrike">
-                <a:solidFill>
-                  <a:schemeClr val="dk1"/>
-                </a:solidFill>
-                <a:latin typeface="Calibri"/>
-              </a:rPr>
-              <a:t> </a:t>
-            </a:r>
-            <a:r>
-              <a:rPr b="0" lang="en-US" sz="4400" spc="-1" strike="noStrike">
-                <a:solidFill>
-                  <a:schemeClr val="dk1"/>
-                </a:solidFill>
-                <a:latin typeface="Calibri"/>
-              </a:rPr>
-              <a:t>s</a:t>
-            </a:r>
-            <a:r>
-              <a:rPr b="0" lang="en-US" sz="4400" spc="-1" strike="noStrike">
-                <a:solidFill>
-                  <a:schemeClr val="dk1"/>
-                </a:solidFill>
-                <a:latin typeface="Calibri"/>
-              </a:rPr>
-              <a:t>t</a:t>
-            </a:r>
-            <a:r>
-              <a:rPr b="0" lang="en-US" sz="4400" spc="-1" strike="noStrike">
-                <a:solidFill>
-                  <a:schemeClr val="dk1"/>
-                </a:solidFill>
-                <a:latin typeface="Calibri"/>
-              </a:rPr>
-              <a:t>y</a:t>
-            </a:r>
-            <a:r>
-              <a:rPr b="0" lang="en-US" sz="4400" spc="-1" strike="noStrike">
-                <a:solidFill>
-                  <a:schemeClr val="dk1"/>
-                </a:solidFill>
-                <a:latin typeface="Calibri"/>
-              </a:rPr>
-              <a:t>l</a:t>
+              <a:t>yl</a:t>
             </a:r>
             <a:r>
               <a:rPr b="0" lang="en-US" sz="4400" spc="-1" strike="noStrike">
@@ -3818,7 +3990,7 @@
               </a:lnSpc>
               <a:buNone/>
             </a:pPr>
-            <a:fld id="{49D477C6-AEBB-4775-BC7E-033BE1A31FF2}" type="slidenum">
+            <a:fld id="{B28C77E5-7A9B-4A73-A961-5785328808ED}" type="slidenum">
               <a:rPr b="0" lang="en-US" sz="1200" spc="-1" strike="noStrike">
                 <a:solidFill>
                   <a:schemeClr val="dk1">
@@ -3912,7 +4084,52 @@
                 </a:solidFill>
                 <a:latin typeface="Calibri"/>
               </a:rPr>
-              <a:t>Click to edit Master title style</a:t>
+              <a:t>Click </a:t>
+            </a:r>
+            <a:r>
+              <a:rPr b="0" lang="en-US" sz="4400" spc="-1" strike="noStrike">
+                <a:solidFill>
+                  <a:schemeClr val="dk1"/>
+                </a:solidFill>
+                <a:latin typeface="Calibri"/>
+              </a:rPr>
+              <a:t>to </a:t>
+            </a:r>
+            <a:r>
+              <a:rPr b="0" lang="en-US" sz="4400" spc="-1" strike="noStrike">
+                <a:solidFill>
+                  <a:schemeClr val="dk1"/>
+                </a:solidFill>
+                <a:latin typeface="Calibri"/>
+              </a:rPr>
+              <a:t>edit </a:t>
+            </a:r>
+            <a:r>
+              <a:rPr b="0" lang="en-US" sz="4400" spc="-1" strike="noStrike">
+                <a:solidFill>
+                  <a:schemeClr val="dk1"/>
+                </a:solidFill>
+                <a:latin typeface="Calibri"/>
+              </a:rPr>
+              <a:t>Maste</a:t>
+            </a:r>
+            <a:r>
+              <a:rPr b="0" lang="en-US" sz="4400" spc="-1" strike="noStrike">
+                <a:solidFill>
+                  <a:schemeClr val="dk1"/>
+                </a:solidFill>
+                <a:latin typeface="Calibri"/>
+              </a:rPr>
+              <a:t>r title </a:t>
+            </a:r>
+            <a:r>
+              <a:rPr b="0" lang="en-US" sz="4400" spc="-1" strike="noStrike">
+                <a:solidFill>
+                  <a:schemeClr val="dk1"/>
+                </a:solidFill>
+                <a:latin typeface="Calibri"/>
+              </a:rPr>
+              <a:t>style</a:t>
             </a:r>
             <a:endParaRPr b="0" lang="en-US" sz="4400" spc="-1" strike="noStrike">
               <a:solidFill>
@@ -4282,7 +4499,7 @@
               </a:lnSpc>
               <a:buNone/>
             </a:pPr>
-            <a:fld id="{EACBC8BD-5EDB-4067-A221-67E84A2C6E3E}" type="slidenum">
+            <a:fld id="{23DBB6DE-2BC9-429E-8E93-02141BD98BA1}" type="slidenum">
               <a:rPr b="0" lang="en-US" sz="1200" spc="-1" strike="noStrike">
                 <a:solidFill>
                   <a:schemeClr val="dk1">
@@ -4376,7 +4593,7 @@
                 </a:solidFill>
                 <a:latin typeface="Calibri"/>
               </a:rPr>
-              <a:t>Click </a:t>
+              <a:t>C</a:t>
             </a:r>
             <a:r>
               <a:rPr b="1" lang="en-US" sz="4000" spc="-1" strike="noStrike" cap="all">
@@ -4385,7 +4602,7 @@
                 </a:solidFill>
                 <a:latin typeface="Calibri"/>
               </a:rPr>
-              <a:t>to </a:t>
+              <a:t>l</a:t>
             </a:r>
             <a:r>
               <a:rPr b="1" lang="en-US" sz="4000" spc="-1" strike="noStrike" cap="all">
@@ -4394,7 +4611,7 @@
                 </a:solidFill>
                 <a:latin typeface="Calibri"/>
               </a:rPr>
-              <a:t>edit </a:t>
+              <a:t>i</a:t>
             </a:r>
             <a:r>
               <a:rPr b="1" lang="en-US" sz="4000" spc="-1" strike="noStrike" cap="all">
@@ -4403,7 +4620,7 @@
                 </a:solidFill>
                 <a:latin typeface="Calibri"/>
               </a:rPr>
-              <a:t>Mast</a:t>
+              <a:t>c</a:t>
             </a:r>
             <a:r>
               <a:rPr b="1" lang="en-US" sz="4000" spc="-1" strike="noStrike" cap="all">
@@ -4412,7 +4629,7 @@
                 </a:solidFill>
                 <a:latin typeface="Calibri"/>
               </a:rPr>
-              <a:t>er </a:t>
+              <a:t>k</a:t>
             </a:r>
             <a:r>
               <a:rPr b="1" lang="en-US" sz="4000" spc="-1" strike="noStrike" cap="all">
@@ -4421,7 +4638,7 @@
                 </a:solidFill>
                 <a:latin typeface="Calibri"/>
               </a:rPr>
-              <a:t>title </a:t>
+              <a:t> </a:t>
             </a:r>
             <a:r>
               <a:rPr b="1" lang="en-US" sz="4000" spc="-1" strike="noStrike" cap="all">
@@ -4430,7 +4647,232 @@
                 </a:solidFill>
                 <a:latin typeface="Calibri"/>
               </a:rPr>
-              <a:t>style</a:t>
+              <a:t>t</a:t>
+            </a:r>
+            <a:r>
+              <a:rPr b="1" lang="en-US" sz="4000" spc="-1" strike="noStrike" cap="all">
+                <a:solidFill>
+                  <a:schemeClr val="dk1"/>
+                </a:solidFill>
+                <a:latin typeface="Calibri"/>
+              </a:rPr>
+              <a:t>o</a:t>
+            </a:r>
+            <a:r>
+              <a:rPr b="1" lang="en-US" sz="4000" spc="-1" strike="noStrike" cap="all">
+                <a:solidFill>
+                  <a:schemeClr val="dk1"/>
+                </a:solidFill>
+                <a:latin typeface="Calibri"/>
+              </a:rPr>
+              <a:t> </a:t>
+            </a:r>
+            <a:r>
+              <a:rPr b="1" lang="en-US" sz="4000" spc="-1" strike="noStrike" cap="all">
+                <a:solidFill>
+                  <a:schemeClr val="dk1"/>
+                </a:solidFill>
+                <a:latin typeface="Calibri"/>
+              </a:rPr>
+              <a:t>e</a:t>
+            </a:r>
+            <a:r>
+              <a:rPr b="1" lang="en-US" sz="4000" spc="-1" strike="noStrike" cap="all">
+                <a:solidFill>
+                  <a:schemeClr val="dk1"/>
+                </a:solidFill>
+                <a:latin typeface="Calibri"/>
+              </a:rPr>
+              <a:t>d</a:t>
+            </a:r>
+            <a:r>
+              <a:rPr b="1" lang="en-US" sz="4000" spc="-1" strike="noStrike" cap="all">
+                <a:solidFill>
+                  <a:schemeClr val="dk1"/>
+                </a:solidFill>
+                <a:latin typeface="Calibri"/>
+              </a:rPr>
+              <a:t>i</a:t>
+            </a:r>
+            <a:r>
+              <a:rPr b="1" lang="en-US" sz="4000" spc="-1" strike="noStrike" cap="all">
+                <a:solidFill>
+                  <a:schemeClr val="dk1"/>
+                </a:solidFill>
+                <a:latin typeface="Calibri"/>
+              </a:rPr>
+              <a:t>t</a:t>
+            </a:r>
+            <a:r>
+              <a:rPr b="1" lang="en-US" sz="4000" spc="-1" strike="noStrike" cap="all">
+                <a:solidFill>
+                  <a:schemeClr val="dk1"/>
+                </a:solidFill>
+                <a:latin typeface="Calibri"/>
+              </a:rPr>
+              <a:t> </a:t>
+            </a:r>
+            <a:r>
+              <a:rPr b="1" lang="en-US" sz="4000" spc="-1" strike="noStrike" cap="all">
+                <a:solidFill>
+                  <a:schemeClr val="dk1"/>
+                </a:solidFill>
+                <a:latin typeface="Calibri"/>
+              </a:rPr>
+              <a:t>M</a:t>
+            </a:r>
+            <a:r>
+              <a:rPr b="1" lang="en-US" sz="4000" spc="-1" strike="noStrike" cap="all">
+                <a:solidFill>
+                  <a:schemeClr val="dk1"/>
+                </a:solidFill>
+                <a:latin typeface="Calibri"/>
+              </a:rPr>
+              <a:t>a</a:t>
+            </a:r>
+            <a:r>
+              <a:rPr b="1" lang="en-US" sz="4000" spc="-1" strike="noStrike" cap="all">
+                <a:solidFill>
+                  <a:schemeClr val="dk1"/>
+                </a:solidFill>
+                <a:latin typeface="Calibri"/>
+              </a:rPr>
+              <a:t>s</a:t>
+            </a:r>
+            <a:r>
+              <a:rPr b="1" lang="en-US" sz="4000" spc="-1" strike="noStrike" cap="all">
+                <a:solidFill>
+                  <a:schemeClr val="dk1"/>
+                </a:solidFill>
+                <a:latin typeface="Calibri"/>
+              </a:rPr>
+              <a:t>t</a:t>
+            </a:r>
+            <a:r>
+              <a:rPr b="1" lang="en-US" sz="4000" spc="-1" strike="noStrike" cap="all">
+                <a:solidFill>
+                  <a:schemeClr val="dk1"/>
+                </a:solidFill>
+                <a:latin typeface="Calibri"/>
+              </a:rPr>
+              <a:t>e</a:t>
+            </a:r>
+            <a:r>
+              <a:rPr b="1" lang="en-US" sz="4000" spc="-1" strike="noStrike" cap="all">
+                <a:solidFill>
+                  <a:schemeClr val="dk1"/>
+                </a:solidFill>
+                <a:latin typeface="Calibri"/>
+              </a:rPr>
+              <a:t>r</a:t>
+            </a:r>
+            <a:r>
+              <a:rPr b="1" lang="en-US" sz="4000" spc="-1" strike="noStrike" cap="all">
+                <a:solidFill>
+                  <a:schemeClr val="dk1"/>
+                </a:solidFill>
+                <a:latin typeface="Calibri"/>
+              </a:rPr>
+              <a:t> </a:t>
+            </a:r>
+            <a:r>
+              <a:rPr b="1" lang="en-US" sz="4000" spc="-1" strike="noStrike" cap="all">
+                <a:solidFill>
+                  <a:schemeClr val="dk1"/>
+                </a:solidFill>
+                <a:latin typeface="Calibri"/>
+              </a:rPr>
+              <a:t>t</a:t>
+            </a:r>
+            <a:r>
+              <a:rPr b="1" lang="en-US" sz="4000" spc="-1" strike="noStrike" cap="all">
+                <a:solidFill>
+                  <a:schemeClr val="dk1"/>
+                </a:solidFill>
+                <a:latin typeface="Calibri"/>
+              </a:rPr>
+              <a:t>i</a:t>
+            </a:r>
+            <a:r>
+              <a:rPr b="1" lang="en-US" sz="4000" spc="-1" strike="noStrike" cap="all">
+                <a:solidFill>
+                  <a:schemeClr val="dk1"/>
+                </a:solidFill>
+                <a:latin typeface="Calibri"/>
+              </a:rPr>
+              <a:t>t</a:t>
+            </a:r>
+            <a:r>
+              <a:rPr b="1" lang="en-US" sz="4000" spc="-1" strike="noStrike" cap="all">
+                <a:solidFill>
+                  <a:schemeClr val="dk1"/>
+                </a:solidFill>
+                <a:latin typeface="Calibri"/>
+              </a:rPr>
+              <a:t>l</a:t>
+            </a:r>
+            <a:r>
+              <a:rPr b="1" lang="en-US" sz="4000" spc="-1" strike="noStrike" cap="all">
+                <a:solidFill>
+                  <a:schemeClr val="dk1"/>
+                </a:solidFill>
+                <a:latin typeface="Calibri"/>
+              </a:rPr>
+              <a:t>e</a:t>
+            </a:r>
+            <a:r>
+              <a:rPr b="1" lang="en-US" sz="4000" spc="-1" strike="noStrike" cap="all">
+                <a:solidFill>
+                  <a:schemeClr val="dk1"/>
+                </a:solidFill>
+                <a:latin typeface="Calibri"/>
+              </a:rPr>
+              <a:t> </a:t>
+            </a:r>
+            <a:r>
+              <a:rPr b="1" lang="en-US" sz="4000" spc="-1" strike="noStrike" cap="all">
+                <a:solidFill>
+                  <a:schemeClr val="dk1"/>
+                </a:solidFill>
+                <a:latin typeface="Calibri"/>
+              </a:rPr>
+              <a:t>s</a:t>
+            </a:r>
+            <a:r>
+              <a:rPr b="1" lang="en-US" sz="4000" spc="-1" strike="noStrike" cap="all">
+                <a:solidFill>
+                  <a:schemeClr val="dk1"/>
+                </a:solidFill>
+                <a:latin typeface="Calibri"/>
+              </a:rPr>
+              <a:t>t</a:t>
+            </a:r>
+            <a:r>
+              <a:rPr b="1" lang="en-US" sz="4000" spc="-1" strike="noStrike" cap="all">
+                <a:solidFill>
+                  <a:schemeClr val="dk1"/>
+                </a:solidFill>
+                <a:latin typeface="Calibri"/>
+              </a:rPr>
+              <a:t>y</a:t>
+            </a:r>
+            <a:r>
+              <a:rPr b="1" lang="en-US" sz="4000" spc="-1" strike="noStrike" cap="all">
+                <a:solidFill>
+                  <a:schemeClr val="dk1"/>
+                </a:solidFill>
+                <a:latin typeface="Calibri"/>
+              </a:rPr>
+              <a:t>l</a:t>
+            </a:r>
+            <a:r>
+              <a:rPr b="1" lang="en-US" sz="4000" spc="-1" strike="noStrike" cap="all">
+                <a:solidFill>
+                  <a:schemeClr val="dk1"/>
+                </a:solidFill>
+                <a:latin typeface="Calibri"/>
+              </a:rPr>
+              <a:t>e</a:t>
             </a:r>
             <a:endParaRPr b="0" lang="en-US" sz="4000" spc="-1" strike="noStrike">
               <a:solidFill>
@@ -4681,7 +5123,7 @@
               </a:lnSpc>
               <a:buNone/>
             </a:pPr>
-            <a:fld id="{BA96776B-1E27-44FA-9B4D-E825CADA61C3}" type="slidenum">
+            <a:fld id="{0143DE4A-C56A-476E-AAF1-8E9BE5948FAA}" type="slidenum">
               <a:rPr b="0" lang="en-US" sz="1200" spc="-1" strike="noStrike">
                 <a:solidFill>
                   <a:schemeClr val="dk1">
@@ -5324,7 +5766,7 @@
               </a:lnSpc>
               <a:buNone/>
             </a:pPr>
-            <a:fld id="{D0CA6252-88E9-45DD-92C4-0E2CD5780E96}" type="slidenum">
+            <a:fld id="{BEAB7832-DD4A-4193-A5B7-83B36E2F3E9C}" type="slidenum">
               <a:rPr b="0" lang="en-US" sz="1200" spc="-1" strike="noStrike">
                 <a:solidFill>
                   <a:schemeClr val="dk1">
@@ -5418,34 +5860,7 @@
                 </a:solidFill>
                 <a:latin typeface="Calibri"/>
               </a:rPr>
-              <a:t>Click to </a:t>
-            </a:r>
-            <a:r>
-              <a:rPr b="0" lang="en-US" sz="4400" spc="-1" strike="noStrike">
-                <a:solidFill>
-                  <a:schemeClr val="dk1"/>
-                </a:solidFill>
-                <a:latin typeface="Calibri"/>
-              </a:rPr>
-              <a:t>edit </a:t>
-            </a:r>
-            <a:r>
-              <a:rPr b="0" lang="en-US" sz="4400" spc="-1" strike="noStrike">
-                <a:solidFill>
-                  <a:schemeClr val="dk1"/>
-                </a:solidFill>
-                <a:latin typeface="Calibri"/>
-              </a:rPr>
-              <a:t>Master </a:t>
-            </a:r>
-            <a:r>
-              <a:rPr b="0" lang="en-US" sz="4400" spc="-1" strike="noStrike">
-                <a:solidFill>
-                  <a:schemeClr val="dk1"/>
-                </a:solidFill>
-                <a:latin typeface="Calibri"/>
-              </a:rPr>
-              <a:t>title style</a:t>
+              <a:t>Click to edit Master title style</a:t>
             </a:r>
             <a:endParaRPr b="0" lang="en-US" sz="4400" spc="-1" strike="noStrike">
               <a:solidFill>
@@ -6110,7 +6525,7 @@
               </a:lnSpc>
               <a:buNone/>
             </a:pPr>
-            <a:fld id="{373514E4-73BC-4CD8-A7AF-CA426EEE23DA}" type="slidenum">
+            <a:fld id="{1F1C6915-48E8-4DCE-AB2F-5020B5288E72}" type="slidenum">
               <a:rPr b="0" lang="en-US" sz="1200" spc="-1" strike="noStrike">
                 <a:solidFill>
                   <a:schemeClr val="dk1">
@@ -6395,7 +6810,7 @@
               </a:lnSpc>
               <a:buNone/>
             </a:pPr>
-            <a:fld id="{84F56EEE-1707-41BB-B362-3B1583A189E2}" type="slidenum">
+            <a:fld id="{72DAA768-1E49-4540-BD1A-22C9B30C9547}" type="slidenum">
               <a:rPr b="0" lang="en-US" sz="1200" spc="-1" strike="noStrike">
                 <a:solidFill>
                   <a:schemeClr val="dk1">
@@ -6628,7 +7043,7 @@
               </a:lnSpc>
               <a:buNone/>
             </a:pPr>
-            <a:fld id="{FF65B1D3-9B7D-4437-A87B-FD84B4D70387}" type="slidenum">
+            <a:fld id="{B4B2787D-EEB3-42DF-976D-6478D44BB6D9}" type="slidenum">
               <a:rPr b="0" lang="en-US" sz="1200" spc="-1" strike="noStrike">
                 <a:solidFill>
                   <a:schemeClr val="dk1">
@@ -7379,7 +7794,7 @@
                 </a:solidFill>
                 <a:latin typeface="Calibri"/>
               </a:rPr>
-              <a:t>1 / 20</a:t>
+              <a:t>1 / 21</a:t>
             </a:r>
             <a:endParaRPr b="0" lang="en-US" sz="1000" spc="-1" strike="noStrike">
               <a:solidFill>
@@ -9022,7 +9437,7 @@
                 </a:solidFill>
                 <a:latin typeface="Calibri"/>
               </a:rPr>
-              <a:t>10 / 20</a:t>
+              <a:t>10 / 21</a:t>
             </a:r>
             <a:endParaRPr b="0" lang="en-US" sz="1000" spc="-1" strike="noStrike">
               <a:solidFill>
@@ -11361,7 +11776,7 @@
                 </a:solidFill>
                 <a:latin typeface="Calibri"/>
               </a:rPr>
-              <a:t>11 / 20</a:t>
+              <a:t>11 / 21</a:t>
             </a:r>
             <a:endParaRPr b="0" lang="en-US" sz="1000" spc="-1" strike="noStrike">
               <a:solidFill>
@@ -13197,7 +13612,7 @@
                 </a:solidFill>
                 <a:latin typeface="Calibri"/>
               </a:rPr>
-              <a:t>12 / 20</a:t>
+              <a:t>12 / 21</a:t>
             </a:r>
             <a:endParaRPr b="0" lang="en-US" sz="1000" spc="-1" strike="noStrike">
               <a:solidFill>
@@ -15159,7 +15574,7 @@
                 </a:solidFill>
                 <a:latin typeface="Calibri"/>
               </a:rPr>
-              <a:t>13 / 20</a:t>
+              <a:t>13 / 21</a:t>
             </a:r>
             <a:endParaRPr b="0" lang="en-US" sz="1000" spc="-1" strike="noStrike">
               <a:solidFill>
@@ -17995,7 +18410,7 @@
                 </a:solidFill>
                 <a:latin typeface="Calibri"/>
               </a:rPr>
-              <a:t>14 / 20</a:t>
+              <a:t>14 / 21</a:t>
             </a:r>
             <a:endParaRPr b="0" lang="en-US" sz="1000" spc="-1" strike="noStrike">
               <a:solidFill>
@@ -21081,7 +21496,7 @@
                 </a:solidFill>
                 <a:latin typeface="Calibri"/>
               </a:rPr>
-              <a:t>15 / 20</a:t>
+              <a:t>15 / 21</a:t>
             </a:r>
             <a:endParaRPr b="0" lang="en-US" sz="1000" spc="-1" strike="noStrike">
               <a:solidFill>
@@ -24458,7 +24873,7 @@
                 </a:solidFill>
                 <a:latin typeface="Calibri"/>
               </a:rPr>
-              <a:t>16 / 20</a:t>
+              <a:t>16 / 21</a:t>
             </a:r>
             <a:endParaRPr b="0" lang="en-US" sz="1000" spc="-1" strike="noStrike">
               <a:solidFill>
@@ -27201,7 +27616,7 @@
                 </a:solidFill>
                 <a:latin typeface="Calibri"/>
               </a:rPr>
-              <a:t>17 / 20</a:t>
+              <a:t>17 / 21</a:t>
             </a:r>
             <a:endParaRPr b="0" lang="en-US" sz="1000" spc="-1" strike="noStrike">
               <a:solidFill>
@@ -30470,7 +30885,7 @@
                 </a:solidFill>
                 <a:latin typeface="Calibri"/>
               </a:rPr>
-              <a:t>18 / 20</a:t>
+              <a:t>18 / 21</a:t>
             </a:r>
             <a:endParaRPr b="0" lang="en-US" sz="1000" spc="-1" strike="noStrike">
               <a:solidFill>
@@ -30578,7 +30993,7 @@
         </p:nvSpPr>
         <p:spPr>
           <a:xfrm>
-            <a:off x="360" y="6218280"/>
+            <a:off x="0" y="6218280"/>
             <a:ext cx="12188520" cy="182520"/>
           </a:xfrm>
           <a:prstGeom prst="rect">
@@ -32180,7 +32595,7 @@
                 </a:solidFill>
                 <a:latin typeface="Calibri"/>
               </a:rPr>
-              <a:t>19 / 20</a:t>
+              <a:t>19 / 21</a:t>
             </a:r>
             <a:endParaRPr b="0" lang="en-US" sz="1000" spc="-1" strike="noStrike">
               <a:solidFill>
@@ -33478,7 +33893,7 @@
                 </a:solidFill>
                 <a:latin typeface="Calibri"/>
               </a:rPr>
-              <a:t>2 / 20</a:t>
+              <a:t>2 / 21</a:t>
             </a:r>
             <a:endParaRPr b="0" lang="en-US" sz="1000" spc="-1" strike="noStrike">
               <a:solidFill>
@@ -33534,7 +33949,7 @@
             <a:avLst/>
           </a:prstGeom>
           <a:solidFill>
-            <a:srgbClr val="1a3264"/>
+            <a:srgbClr val="f0f4ff"/>
           </a:solidFill>
           <a:ln>
             <a:noFill/>
@@ -33586,14 +34001,14 @@
         </p:nvSpPr>
         <p:spPr>
           <a:xfrm>
-            <a:off x="-72720" y="5605560"/>
-            <a:ext cx="12188520" cy="109440"/>
+            <a:off x="0" y="0"/>
+            <a:ext cx="12188520" cy="1234080"/>
           </a:xfrm>
           <a:prstGeom prst="rect">
             <a:avLst/>
           </a:prstGeom>
           <a:solidFill>
-            <a:srgbClr val="e8a838"/>
+            <a:srgbClr val="1a3264"/>
           </a:solidFill>
           <a:ln>
             <a:noFill/>
@@ -33639,14 +34054,120 @@
       </p:sp>
       <p:sp>
         <p:nvSpPr>
-          <p:cNvPr id="736" name="Rectangle 3"/>
-          <p:cNvSpPr/>
-          <p:nvPr/>
-        </p:nvSpPr>
-        <p:spPr>
-          <a:xfrm>
-            <a:off x="0" y="0"/>
-            <a:ext cx="164160" cy="6857640"/>
+          <p:cNvPr id="736" name="TextBox 3"/>
+          <p:cNvSpPr/>
+          <p:nvPr/>
+        </p:nvSpPr>
+        <p:spPr>
+          <a:xfrm>
+            <a:off x="365760" y="91440"/>
+            <a:ext cx="9143640" cy="516600"/>
+          </a:xfrm>
+          <a:prstGeom prst="rect">
+            <a:avLst/>
+          </a:prstGeom>
+          <a:noFill/>
+          <a:ln w="0">
+            <a:noFill/>
+          </a:ln>
+        </p:spPr>
+        <p:style>
+          <a:lnRef idx="0"/>
+          <a:fillRef idx="0"/>
+          <a:effectRef idx="0"/>
+          <a:fontRef idx="minor"/>
+        </p:style>
+        <p:txBody>
+          <a:bodyPr lIns="90000" rIns="90000" tIns="45000" bIns="45000" anchor="t">
+            <a:spAutoFit/>
+          </a:bodyPr>
+          <a:p>
+            <a:pPr defTabSz="457200">
+              <a:lnSpc>
+                <a:spcPct val="100000"/>
+              </a:lnSpc>
+            </a:pPr>
+            <a:r>
+              <a:rPr b="1" lang="en-US" sz="2800" spc="-1" strike="noStrike">
+                <a:solidFill>
+                  <a:srgbClr val="ffffff"/>
+                </a:solidFill>
+                <a:latin typeface="Calibri"/>
+              </a:rPr>
+              <a:t>Roadmap — рекомендации по развитию</a:t>
+            </a:r>
+            <a:endParaRPr b="0" lang="en-US" sz="2800" spc="-1" strike="noStrike">
+              <a:solidFill>
+                <a:srgbClr val="000000"/>
+              </a:solidFill>
+              <a:latin typeface="Arial"/>
+            </a:endParaRPr>
+          </a:p>
+        </p:txBody>
+      </p:sp>
+      <p:sp>
+        <p:nvSpPr>
+          <p:cNvPr id="737" name="TextBox 4"/>
+          <p:cNvSpPr/>
+          <p:nvPr/>
+        </p:nvSpPr>
+        <p:spPr>
+          <a:xfrm>
+            <a:off x="365760" y="694800"/>
+            <a:ext cx="10058040" cy="288000"/>
+          </a:xfrm>
+          <a:prstGeom prst="rect">
+            <a:avLst/>
+          </a:prstGeom>
+          <a:noFill/>
+          <a:ln w="0">
+            <a:noFill/>
+          </a:ln>
+        </p:spPr>
+        <p:style>
+          <a:lnRef idx="0"/>
+          <a:fillRef idx="0"/>
+          <a:effectRef idx="0"/>
+          <a:fontRef idx="minor"/>
+        </p:style>
+        <p:txBody>
+          <a:bodyPr lIns="90000" rIns="90000" tIns="45000" bIns="45000" anchor="t">
+            <a:spAutoFit/>
+          </a:bodyPr>
+          <a:p>
+            <a:pPr defTabSz="457200">
+              <a:lnSpc>
+                <a:spcPct val="100000"/>
+              </a:lnSpc>
+            </a:pPr>
+            <a:r>
+              <a:rPr b="0" i="1" lang="en-US" sz="1300" spc="-1" strike="noStrike">
+                <a:solidFill>
+                  <a:srgbClr val="e8a838"/>
+                </a:solidFill>
+                <a:latin typeface="Calibri"/>
+              </a:rPr>
+              <a:t>От MVP к production-решению для 10 000+ сотрудников</a:t>
+            </a:r>
+            <a:endParaRPr b="0" lang="en-US" sz="1300" spc="-1" strike="noStrike">
+              <a:solidFill>
+                <a:srgbClr val="000000"/>
+              </a:solidFill>
+              <a:latin typeface="Arial"/>
+            </a:endParaRPr>
+          </a:p>
+        </p:txBody>
+      </p:sp>
+      <p:sp>
+        <p:nvSpPr>
+          <p:cNvPr id="738" name="Rectangle 5"/>
+          <p:cNvSpPr/>
+          <p:nvPr/>
+        </p:nvSpPr>
+        <p:spPr>
+          <a:xfrm>
+            <a:off x="0" y="1234440"/>
+            <a:ext cx="12188520" cy="54360"/>
           </a:xfrm>
           <a:prstGeom prst="rect">
             <a:avLst/>
@@ -33678,7 +34199,7 @@
           <a:fontRef idx="minor"/>
         </p:style>
         <p:txBody>
-          <a:bodyPr lIns="90000" rIns="90000" tIns="45000" bIns="45000" anchor="ctr">
+          <a:bodyPr lIns="90000" rIns="90000" tIns="9720" bIns="9720" anchor="ctr">
             <a:noAutofit/>
           </a:bodyPr>
           <a:p>
@@ -33698,73 +34219,20 @@
       </p:sp>
       <p:sp>
         <p:nvSpPr>
-          <p:cNvPr id="737" name="TextBox 4"/>
-          <p:cNvSpPr/>
-          <p:nvPr/>
-        </p:nvSpPr>
-        <p:spPr>
-          <a:xfrm>
-            <a:off x="457200" y="548640"/>
-            <a:ext cx="11274120" cy="699120"/>
-          </a:xfrm>
-          <a:prstGeom prst="rect">
-            <a:avLst/>
-          </a:prstGeom>
-          <a:noFill/>
-          <a:ln w="0">
-            <a:noFill/>
-          </a:ln>
-        </p:spPr>
-        <p:style>
-          <a:lnRef idx="0"/>
-          <a:fillRef idx="0"/>
-          <a:effectRef idx="0"/>
-          <a:fontRef idx="minor"/>
-        </p:style>
-        <p:txBody>
-          <a:bodyPr lIns="90000" rIns="90000" tIns="45000" bIns="45000" anchor="t">
-            <a:spAutoFit/>
-          </a:bodyPr>
-          <a:p>
-            <a:pPr algn="ctr" defTabSz="457200">
-              <a:lnSpc>
-                <a:spcPct val="100000"/>
-              </a:lnSpc>
-            </a:pPr>
-            <a:r>
-              <a:rPr b="1" lang="en-US" sz="4000" spc="-1" strike="noStrike">
-                <a:solidFill>
-                  <a:srgbClr val="ffffff"/>
-                </a:solidFill>
-                <a:latin typeface="Calibri"/>
-              </a:rPr>
-              <a:t>Спасибо за внимание</a:t>
-            </a:r>
-            <a:endParaRPr b="0" lang="en-US" sz="4000" spc="-1" strike="noStrike">
-              <a:solidFill>
-                <a:srgbClr val="000000"/>
-              </a:solidFill>
-              <a:latin typeface="Arial"/>
-            </a:endParaRPr>
-          </a:p>
-        </p:txBody>
-      </p:sp>
-      <p:sp>
-        <p:nvSpPr>
-          <p:cNvPr id="738" name="Rectangle 5"/>
-          <p:cNvSpPr/>
-          <p:nvPr/>
-        </p:nvSpPr>
-        <p:spPr>
-          <a:xfrm>
-            <a:off x="320040" y="1508760"/>
-            <a:ext cx="3565800" cy="1691280"/>
+          <p:cNvPr id="739" name="Rectangle 6"/>
+          <p:cNvSpPr/>
+          <p:nvPr/>
+        </p:nvSpPr>
+        <p:spPr>
+          <a:xfrm>
+            <a:off x="274320" y="1417320"/>
+            <a:ext cx="5687280" cy="2331360"/>
           </a:xfrm>
           <a:prstGeom prst="rect">
             <a:avLst/>
           </a:prstGeom>
           <a:solidFill>
-            <a:srgbClr val="0d1b3e"/>
+            <a:srgbClr val="ffffff"/>
           </a:solidFill>
           <a:ln>
             <a:noFill/>
@@ -33810,20 +34278,20 @@
       </p:sp>
       <p:sp>
         <p:nvSpPr>
-          <p:cNvPr id="739" name="Rectangle 6"/>
-          <p:cNvSpPr/>
-          <p:nvPr/>
-        </p:nvSpPr>
-        <p:spPr>
-          <a:xfrm>
-            <a:off x="320040" y="1508760"/>
-            <a:ext cx="3565800" cy="72720"/>
+          <p:cNvPr id="740" name="Rectangle 7"/>
+          <p:cNvSpPr/>
+          <p:nvPr/>
+        </p:nvSpPr>
+        <p:spPr>
+          <a:xfrm>
+            <a:off x="274320" y="1417320"/>
+            <a:ext cx="91080" cy="2331360"/>
           </a:xfrm>
           <a:prstGeom prst="rect">
             <a:avLst/>
           </a:prstGeom>
           <a:solidFill>
-            <a:srgbClr val="e8a838"/>
+            <a:srgbClr val="1a3264"/>
           </a:solidFill>
           <a:ln>
             <a:noFill/>
@@ -33849,7 +34317,7 @@
           <a:fontRef idx="minor"/>
         </p:style>
         <p:txBody>
-          <a:bodyPr lIns="90000" rIns="90000" tIns="28080" bIns="28080" anchor="ctr">
+          <a:bodyPr lIns="90000" rIns="90000" tIns="45000" bIns="45000" anchor="ctr">
             <a:noAutofit/>
           </a:bodyPr>
           <a:p>
@@ -33869,14 +34337,14 @@
       </p:sp>
       <p:sp>
         <p:nvSpPr>
-          <p:cNvPr id="740" name="TextBox 7"/>
-          <p:cNvSpPr/>
-          <p:nvPr/>
-        </p:nvSpPr>
-        <p:spPr>
-          <a:xfrm>
-            <a:off x="457200" y="1645920"/>
-            <a:ext cx="3291480" cy="288000"/>
+          <p:cNvPr id="741" name="TextBox 8"/>
+          <p:cNvSpPr/>
+          <p:nvPr/>
+        </p:nvSpPr>
+        <p:spPr>
+          <a:xfrm>
+            <a:off x="457200" y="1554480"/>
+            <a:ext cx="456840" cy="821160"/>
           </a:xfrm>
           <a:prstGeom prst="rect">
             <a:avLst/>
@@ -33903,42 +34371,33 @@
               </a:lnSpc>
             </a:pPr>
             <a:r>
-              <a:rPr b="1" lang="en-US" sz="1300" spc="-1" strike="noStrike">
-                <a:solidFill>
-                  <a:srgbClr val="e8a838"/>
-                </a:solidFill>
-                <a:latin typeface="Calibri"/>
-              </a:rPr>
-              <a:t>🎯  </a:t>
-            </a:r>
-            <a:r>
-              <a:rPr b="1" lang="en-US" sz="1300" spc="-1" strike="noStrike">
-                <a:solidFill>
-                  <a:srgbClr val="e8a838"/>
-                </a:solidFill>
-                <a:latin typeface="Calibri"/>
-              </a:rPr>
-              <a:t>25% + 25%</a:t>
-            </a:r>
-            <a:endParaRPr b="0" lang="en-US" sz="1300" spc="-1" strike="noStrike">
-              <a:solidFill>
-                <a:srgbClr val="000000"/>
-              </a:solidFill>
-              <a:latin typeface="Arial"/>
-            </a:endParaRPr>
-          </a:p>
-        </p:txBody>
-      </p:sp>
-      <p:sp>
-        <p:nvSpPr>
-          <p:cNvPr id="741" name="TextBox 8"/>
-          <p:cNvSpPr/>
-          <p:nvPr/>
-        </p:nvSpPr>
-        <p:spPr>
-          <a:xfrm>
-            <a:off x="457200" y="2020680"/>
-            <a:ext cx="3291480" cy="272520"/>
+              <a:rPr b="0" lang="en-US" sz="2400" spc="-1" strike="noStrike">
+                <a:solidFill>
+                  <a:srgbClr val="ffffff"/>
+                </a:solidFill>
+                <a:latin typeface="Calibri"/>
+              </a:rPr>
+              <a:t>🔐</a:t>
+            </a:r>
+            <a:endParaRPr b="0" lang="en-US" sz="2400" spc="-1" strike="noStrike">
+              <a:solidFill>
+                <a:srgbClr val="000000"/>
+              </a:solidFill>
+              <a:latin typeface="Arial"/>
+            </a:endParaRPr>
+          </a:p>
+        </p:txBody>
+      </p:sp>
+      <p:sp>
+        <p:nvSpPr>
+          <p:cNvPr id="742" name="TextBox 9"/>
+          <p:cNvSpPr/>
+          <p:nvPr/>
+        </p:nvSpPr>
+        <p:spPr>
+          <a:xfrm>
+            <a:off x="960120" y="1581840"/>
+            <a:ext cx="4754520" cy="303120"/>
           </a:xfrm>
           <a:prstGeom prst="rect">
             <a:avLst/>
@@ -33965,33 +34424,33 @@
               </a:lnSpc>
             </a:pPr>
             <a:r>
-              <a:rPr b="1" lang="en-US" sz="1200" spc="-1" strike="noStrike">
-                <a:solidFill>
-                  <a:srgbClr val="ffffff"/>
-                </a:solidFill>
-                <a:latin typeface="Calibri"/>
-              </a:rPr>
-              <a:t>SMART-оценка + AI-генерация</a:t>
-            </a:r>
-            <a:endParaRPr b="0" lang="en-US" sz="1200" spc="-1" strike="noStrike">
-              <a:solidFill>
-                <a:srgbClr val="000000"/>
-              </a:solidFill>
-              <a:latin typeface="Arial"/>
-            </a:endParaRPr>
-          </a:p>
-        </p:txBody>
-      </p:sp>
-      <p:sp>
-        <p:nvSpPr>
-          <p:cNvPr id="742" name="TextBox 9"/>
-          <p:cNvSpPr/>
-          <p:nvPr/>
-        </p:nvSpPr>
-        <p:spPr>
-          <a:xfrm>
-            <a:off x="457200" y="2386440"/>
-            <a:ext cx="3291480" cy="242280"/>
+              <a:rPr b="1" lang="en-US" sz="1400" spc="-1" strike="noStrike">
+                <a:solidFill>
+                  <a:srgbClr val="1a3264"/>
+                </a:solidFill>
+                <a:latin typeface="Calibri"/>
+              </a:rPr>
+              <a:t>Keycloak SSO + RBAC</a:t>
+            </a:r>
+            <a:endParaRPr b="0" lang="en-US" sz="1400" spc="-1" strike="noStrike">
+              <a:solidFill>
+                <a:srgbClr val="000000"/>
+              </a:solidFill>
+              <a:latin typeface="Arial"/>
+            </a:endParaRPr>
+          </a:p>
+        </p:txBody>
+      </p:sp>
+      <p:sp>
+        <p:nvSpPr>
+          <p:cNvPr id="743" name="TextBox 10"/>
+          <p:cNvSpPr/>
+          <p:nvPr/>
+        </p:nvSpPr>
+        <p:spPr>
+          <a:xfrm>
+            <a:off x="457200" y="2011680"/>
+            <a:ext cx="5303160" cy="592920"/>
           </a:xfrm>
           <a:prstGeom prst="rect">
             <a:avLst/>
@@ -34012,45 +34471,79 @@
             <a:spAutoFit/>
           </a:bodyPr>
           <a:p>
+            <a:r>
+              <a:rPr b="0" lang="en-US" sz="1100" spc="-1" strike="noStrike">
+                <a:solidFill>
+                  <a:srgbClr val="1a1a2e"/>
+                </a:solidFill>
+                <a:latin typeface="Calibri"/>
+              </a:rPr>
+              <a:t>SSO через Active Directory / Keycloak</a:t>
+            </a:r>
+            <a:endParaRPr b="0" lang="en-US" sz="1100" spc="-1" strike="noStrike">
+              <a:solidFill>
+                <a:srgbClr val="000000"/>
+              </a:solidFill>
+              <a:latin typeface="Arial"/>
+            </a:endParaRPr>
+          </a:p>
+          <a:p>
+            <a:r>
+              <a:rPr b="0" lang="en-US" sz="1100" spc="-1" strike="noStrike">
+                <a:solidFill>
+                  <a:srgbClr val="1a1a2e"/>
+                </a:solidFill>
+                <a:latin typeface="Calibri"/>
+              </a:rPr>
+              <a:t>JWT-токены, роли: сотрудник / руководитель / HR</a:t>
+            </a:r>
+            <a:endParaRPr b="0" lang="en-US" sz="1100" spc="-1" strike="noStrike">
+              <a:solidFill>
+                <a:srgbClr val="000000"/>
+              </a:solidFill>
+              <a:latin typeface="Arial"/>
+            </a:endParaRPr>
+          </a:p>
+          <a:p>
             <a:pPr defTabSz="457200">
               <a:lnSpc>
                 <a:spcPct val="100000"/>
               </a:lnSpc>
             </a:pPr>
             <a:r>
-              <a:rPr b="0" lang="en-US" sz="1000" spc="-1" strike="noStrike">
-                <a:solidFill>
-                  <a:srgbClr val="aaccff"/>
-                </a:solidFill>
-                <a:latin typeface="Calibri"/>
-              </a:rPr>
-              <a:t>Gemini Flash · 5 критериев · goal_type · strategic_alignment</a:t>
-            </a:r>
-            <a:endParaRPr b="0" lang="en-US" sz="1000" spc="-1" strike="noStrike">
-              <a:solidFill>
-                <a:srgbClr val="000000"/>
-              </a:solidFill>
-              <a:latin typeface="Arial"/>
-            </a:endParaRPr>
-          </a:p>
-        </p:txBody>
-      </p:sp>
-      <p:sp>
-        <p:nvSpPr>
-          <p:cNvPr id="743" name="Rectangle 10"/>
-          <p:cNvSpPr/>
-          <p:nvPr/>
-        </p:nvSpPr>
-        <p:spPr>
-          <a:xfrm>
-            <a:off x="4160520" y="1508760"/>
-            <a:ext cx="3565800" cy="1691280"/>
+              <a:rPr b="0" lang="en-US" sz="1100" spc="-1" strike="noStrike">
+                <a:solidFill>
+                  <a:srgbClr val="1a1a2e"/>
+                </a:solidFill>
+                <a:latin typeface="Calibri"/>
+              </a:rPr>
+              <a:t>Убрать выбор сотрудника — автоматически по логину</a:t>
+            </a:r>
+            <a:endParaRPr b="0" lang="en-US" sz="1100" spc="-1" strike="noStrike">
+              <a:solidFill>
+                <a:srgbClr val="000000"/>
+              </a:solidFill>
+              <a:latin typeface="Arial"/>
+            </a:endParaRPr>
+          </a:p>
+        </p:txBody>
+      </p:sp>
+      <p:sp>
+        <p:nvSpPr>
+          <p:cNvPr id="744" name="Rectangle 11"/>
+          <p:cNvSpPr/>
+          <p:nvPr/>
+        </p:nvSpPr>
+        <p:spPr>
+          <a:xfrm>
+            <a:off x="6236280" y="1417320"/>
+            <a:ext cx="5687280" cy="2331360"/>
           </a:xfrm>
           <a:prstGeom prst="rect">
             <a:avLst/>
           </a:prstGeom>
           <a:solidFill>
-            <a:srgbClr val="0d1b3e"/>
+            <a:srgbClr val="ffffff"/>
           </a:solidFill>
           <a:ln>
             <a:noFill/>
@@ -34096,20 +34589,20 @@
       </p:sp>
       <p:sp>
         <p:nvSpPr>
-          <p:cNvPr id="744" name="Rectangle 11"/>
-          <p:cNvSpPr/>
-          <p:nvPr/>
-        </p:nvSpPr>
-        <p:spPr>
-          <a:xfrm>
-            <a:off x="4160520" y="1508760"/>
-            <a:ext cx="3565800" cy="72720"/>
+          <p:cNvPr id="745" name="Rectangle 12"/>
+          <p:cNvSpPr/>
+          <p:nvPr/>
+        </p:nvSpPr>
+        <p:spPr>
+          <a:xfrm>
+            <a:off x="6236280" y="1417320"/>
+            <a:ext cx="91080" cy="2331360"/>
           </a:xfrm>
           <a:prstGeom prst="rect">
             <a:avLst/>
           </a:prstGeom>
           <a:solidFill>
-            <a:srgbClr val="e8a838"/>
+            <a:srgbClr val="6a1b9a"/>
           </a:solidFill>
           <a:ln>
             <a:noFill/>
@@ -34135,7 +34628,7 @@
           <a:fontRef idx="minor"/>
         </p:style>
         <p:txBody>
-          <a:bodyPr lIns="90000" rIns="90000" tIns="28080" bIns="28080" anchor="ctr">
+          <a:bodyPr lIns="90000" rIns="90000" tIns="45000" bIns="45000" anchor="ctr">
             <a:noAutofit/>
           </a:bodyPr>
           <a:p>
@@ -34155,14 +34648,14 @@
       </p:sp>
       <p:sp>
         <p:nvSpPr>
-          <p:cNvPr id="745" name="TextBox 12"/>
-          <p:cNvSpPr/>
-          <p:nvPr/>
-        </p:nvSpPr>
-        <p:spPr>
-          <a:xfrm>
-            <a:off x="4297680" y="1645920"/>
-            <a:ext cx="3291480" cy="288000"/>
+          <p:cNvPr id="746" name="TextBox 13"/>
+          <p:cNvSpPr/>
+          <p:nvPr/>
+        </p:nvSpPr>
+        <p:spPr>
+          <a:xfrm>
+            <a:off x="6419160" y="1554480"/>
+            <a:ext cx="456840" cy="821160"/>
           </a:xfrm>
           <a:prstGeom prst="rect">
             <a:avLst/>
@@ -34189,42 +34682,33 @@
               </a:lnSpc>
             </a:pPr>
             <a:r>
-              <a:rPr b="1" lang="en-US" sz="1300" spc="-1" strike="noStrike">
-                <a:solidFill>
-                  <a:srgbClr val="e8a838"/>
-                </a:solidFill>
-                <a:latin typeface="Calibri"/>
-              </a:rPr>
-              <a:t>🔍  </a:t>
-            </a:r>
-            <a:r>
-              <a:rPr b="1" lang="en-US" sz="1300" spc="-1" strike="noStrike">
-                <a:solidFill>
-                  <a:srgbClr val="e8a838"/>
-                </a:solidFill>
-                <a:latin typeface="Calibri"/>
-              </a:rPr>
-              <a:t>15%</a:t>
-            </a:r>
-            <a:endParaRPr b="0" lang="en-US" sz="1300" spc="-1" strike="noStrike">
-              <a:solidFill>
-                <a:srgbClr val="000000"/>
-              </a:solidFill>
-              <a:latin typeface="Arial"/>
-            </a:endParaRPr>
-          </a:p>
-        </p:txBody>
-      </p:sp>
-      <p:sp>
-        <p:nvSpPr>
-          <p:cNvPr id="746" name="TextBox 13"/>
-          <p:cNvSpPr/>
-          <p:nvPr/>
-        </p:nvSpPr>
-        <p:spPr>
-          <a:xfrm>
-            <a:off x="4297680" y="2020680"/>
-            <a:ext cx="3291480" cy="272520"/>
+              <a:rPr b="0" lang="en-US" sz="2400" spc="-1" strike="noStrike">
+                <a:solidFill>
+                  <a:srgbClr val="ffffff"/>
+                </a:solidFill>
+                <a:latin typeface="Calibri"/>
+              </a:rPr>
+              <a:t>📄</a:t>
+            </a:r>
+            <a:endParaRPr b="0" lang="en-US" sz="2400" spc="-1" strike="noStrike">
+              <a:solidFill>
+                <a:srgbClr val="000000"/>
+              </a:solidFill>
+              <a:latin typeface="Arial"/>
+            </a:endParaRPr>
+          </a:p>
+        </p:txBody>
+      </p:sp>
+      <p:sp>
+        <p:nvSpPr>
+          <p:cNvPr id="747" name="TextBox 14"/>
+          <p:cNvSpPr/>
+          <p:nvPr/>
+        </p:nvSpPr>
+        <p:spPr>
+          <a:xfrm>
+            <a:off x="6922080" y="1581840"/>
+            <a:ext cx="4754520" cy="303120"/>
           </a:xfrm>
           <a:prstGeom prst="rect">
             <a:avLst/>
@@ -34251,33 +34735,33 @@
               </a:lnSpc>
             </a:pPr>
             <a:r>
-              <a:rPr b="1" lang="en-US" sz="1200" spc="-1" strike="noStrike">
-                <a:solidFill>
-                  <a:srgbClr val="ffffff"/>
-                </a:solidFill>
-                <a:latin typeface="Calibri"/>
-              </a:rPr>
-              <a:t>RAG-пайплайн</a:t>
-            </a:r>
-            <a:endParaRPr b="0" lang="en-US" sz="1200" spc="-1" strike="noStrike">
-              <a:solidFill>
-                <a:srgbClr val="000000"/>
-              </a:solidFill>
-              <a:latin typeface="Arial"/>
-            </a:endParaRPr>
-          </a:p>
-        </p:txBody>
-      </p:sp>
-      <p:sp>
-        <p:nvSpPr>
-          <p:cNvPr id="747" name="TextBox 14"/>
-          <p:cNvSpPr/>
-          <p:nvPr/>
-        </p:nvSpPr>
-        <p:spPr>
-          <a:xfrm>
-            <a:off x="4297680" y="2386440"/>
-            <a:ext cx="3291480" cy="242280"/>
+              <a:rPr b="1" lang="en-US" sz="1400" spc="-1" strike="noStrike">
+                <a:solidFill>
+                  <a:srgbClr val="6a1b9a"/>
+                </a:solidFill>
+                <a:latin typeface="Calibri"/>
+              </a:rPr>
+              <a:t>Парсинг реальных ВНД</a:t>
+            </a:r>
+            <a:endParaRPr b="0" lang="en-US" sz="1400" spc="-1" strike="noStrike">
+              <a:solidFill>
+                <a:srgbClr val="000000"/>
+              </a:solidFill>
+              <a:latin typeface="Arial"/>
+            </a:endParaRPr>
+          </a:p>
+        </p:txBody>
+      </p:sp>
+      <p:sp>
+        <p:nvSpPr>
+          <p:cNvPr id="748" name="TextBox 15"/>
+          <p:cNvSpPr/>
+          <p:nvPr/>
+        </p:nvSpPr>
+        <p:spPr>
+          <a:xfrm>
+            <a:off x="6419160" y="2011680"/>
+            <a:ext cx="5303160" cy="592920"/>
           </a:xfrm>
           <a:prstGeom prst="rect">
             <a:avLst/>
@@ -34298,45 +34782,79 @@
             <a:spAutoFit/>
           </a:bodyPr>
           <a:p>
+            <a:r>
+              <a:rPr b="0" lang="en-US" sz="1100" spc="-1" strike="noStrike">
+                <a:solidFill>
+                  <a:srgbClr val="1a1a2e"/>
+                </a:solidFill>
+                <a:latin typeface="Calibri"/>
+              </a:rPr>
+              <a:t>Word (.docx) и PDF с таблицами, списками, OCR</a:t>
+            </a:r>
+            <a:endParaRPr b="0" lang="en-US" sz="1100" spc="-1" strike="noStrike">
+              <a:solidFill>
+                <a:srgbClr val="000000"/>
+              </a:solidFill>
+              <a:latin typeface="Arial"/>
+            </a:endParaRPr>
+          </a:p>
+          <a:p>
+            <a:r>
+              <a:rPr b="0" lang="en-US" sz="1100" spc="-1" strike="noStrike">
+                <a:solidFill>
+                  <a:srgbClr val="1a1a2e"/>
+                </a:solidFill>
+                <a:latin typeface="Calibri"/>
+              </a:rPr>
+              <a:t>Adaptive chunking по заголовкам</a:t>
+            </a:r>
+            <a:endParaRPr b="0" lang="en-US" sz="1100" spc="-1" strike="noStrike">
+              <a:solidFill>
+                <a:srgbClr val="000000"/>
+              </a:solidFill>
+              <a:latin typeface="Arial"/>
+            </a:endParaRPr>
+          </a:p>
+          <a:p>
             <a:pPr defTabSz="457200">
               <a:lnSpc>
                 <a:spcPct val="100000"/>
               </a:lnSpc>
             </a:pPr>
             <a:r>
-              <a:rPr b="0" lang="en-US" sz="1000" spc="-1" strike="noStrike">
-                <a:solidFill>
-                  <a:srgbClr val="aaccff"/>
-                </a:solidFill>
-                <a:latin typeface="Calibri"/>
-              </a:rPr>
-              <a:t>Qdrant · 160 ВНД · 412 чанков · cosine · source grounding</a:t>
-            </a:r>
-            <a:endParaRPr b="0" lang="en-US" sz="1000" spc="-1" strike="noStrike">
-              <a:solidFill>
-                <a:srgbClr val="000000"/>
-              </a:solidFill>
-              <a:latin typeface="Arial"/>
-            </a:endParaRPr>
-          </a:p>
-        </p:txBody>
-      </p:sp>
-      <p:sp>
-        <p:nvSpPr>
-          <p:cNvPr id="748" name="Rectangle 15"/>
-          <p:cNvSpPr/>
-          <p:nvPr/>
-        </p:nvSpPr>
-        <p:spPr>
-          <a:xfrm>
-            <a:off x="8001000" y="1508760"/>
-            <a:ext cx="3565800" cy="1691280"/>
+              <a:rPr b="0" lang="en-US" sz="1100" spc="-1" strike="noStrike">
+                <a:solidFill>
+                  <a:srgbClr val="1a1a2e"/>
+                </a:solidFill>
+                <a:latin typeface="Calibri"/>
+              </a:rPr>
+              <a:t>Версионирование: автообновление Qdrant при изменении</a:t>
+            </a:r>
+            <a:endParaRPr b="0" lang="en-US" sz="1100" spc="-1" strike="noStrike">
+              <a:solidFill>
+                <a:srgbClr val="000000"/>
+              </a:solidFill>
+              <a:latin typeface="Arial"/>
+            </a:endParaRPr>
+          </a:p>
+        </p:txBody>
+      </p:sp>
+      <p:sp>
+        <p:nvSpPr>
+          <p:cNvPr id="749" name="Rectangle 16"/>
+          <p:cNvSpPr/>
+          <p:nvPr/>
+        </p:nvSpPr>
+        <p:spPr>
+          <a:xfrm>
+            <a:off x="274320" y="3977640"/>
+            <a:ext cx="5687280" cy="2331360"/>
           </a:xfrm>
           <a:prstGeom prst="rect">
             <a:avLst/>
           </a:prstGeom>
           <a:solidFill>
-            <a:srgbClr val="0d1b3e"/>
+            <a:srgbClr val="ffffff"/>
           </a:solidFill>
           <a:ln>
             <a:noFill/>
@@ -34382,20 +34900,20 @@
       </p:sp>
       <p:sp>
         <p:nvSpPr>
-          <p:cNvPr id="749" name="Rectangle 16"/>
-          <p:cNvSpPr/>
-          <p:nvPr/>
-        </p:nvSpPr>
-        <p:spPr>
-          <a:xfrm>
-            <a:off x="8001000" y="1508760"/>
-            <a:ext cx="3565800" cy="72720"/>
+          <p:cNvPr id="750" name="Rectangle 17"/>
+          <p:cNvSpPr/>
+          <p:nvPr/>
+        </p:nvSpPr>
+        <p:spPr>
+          <a:xfrm>
+            <a:off x="274320" y="3977640"/>
+            <a:ext cx="91080" cy="2331360"/>
           </a:xfrm>
           <a:prstGeom prst="rect">
             <a:avLst/>
           </a:prstGeom>
           <a:solidFill>
-            <a:srgbClr val="e8a838"/>
+            <a:srgbClr val="f44336"/>
           </a:solidFill>
           <a:ln>
             <a:noFill/>
@@ -34421,7 +34939,7 @@
           <a:fontRef idx="minor"/>
         </p:style>
         <p:txBody>
-          <a:bodyPr lIns="90000" rIns="90000" tIns="28080" bIns="28080" anchor="ctr">
+          <a:bodyPr lIns="90000" rIns="90000" tIns="45000" bIns="45000" anchor="ctr">
             <a:noAutofit/>
           </a:bodyPr>
           <a:p>
@@ -34441,14 +34959,14 @@
       </p:sp>
       <p:sp>
         <p:nvSpPr>
-          <p:cNvPr id="750" name="TextBox 17"/>
-          <p:cNvSpPr/>
-          <p:nvPr/>
-        </p:nvSpPr>
-        <p:spPr>
-          <a:xfrm>
-            <a:off x="8138160" y="1645920"/>
-            <a:ext cx="3291480" cy="288000"/>
+          <p:cNvPr id="751" name="TextBox 18"/>
+          <p:cNvSpPr/>
+          <p:nvPr/>
+        </p:nvSpPr>
+        <p:spPr>
+          <a:xfrm>
+            <a:off x="457200" y="4114800"/>
+            <a:ext cx="456840" cy="1186920"/>
           </a:xfrm>
           <a:prstGeom prst="rect">
             <a:avLst/>
@@ -34475,42 +34993,33 @@
               </a:lnSpc>
             </a:pPr>
             <a:r>
-              <a:rPr b="1" lang="en-US" sz="1300" spc="-1" strike="noStrike">
-                <a:solidFill>
-                  <a:srgbClr val="e8a838"/>
-                </a:solidFill>
-                <a:latin typeface="Calibri"/>
-              </a:rPr>
-              <a:t>📊  </a:t>
-            </a:r>
-            <a:r>
-              <a:rPr b="1" lang="en-US" sz="1300" spc="-1" strike="noStrike">
-                <a:solidFill>
-                  <a:srgbClr val="e8a838"/>
-                </a:solidFill>
-                <a:latin typeface="Calibri"/>
-              </a:rPr>
-              <a:t>10%</a:t>
-            </a:r>
-            <a:endParaRPr b="0" lang="en-US" sz="1300" spc="-1" strike="noStrike">
-              <a:solidFill>
-                <a:srgbClr val="000000"/>
-              </a:solidFill>
-              <a:latin typeface="Arial"/>
-            </a:endParaRPr>
-          </a:p>
-        </p:txBody>
-      </p:sp>
-      <p:sp>
-        <p:nvSpPr>
-          <p:cNvPr id="751" name="TextBox 18"/>
-          <p:cNvSpPr/>
-          <p:nvPr/>
-        </p:nvSpPr>
-        <p:spPr>
-          <a:xfrm>
-            <a:off x="8138160" y="2020680"/>
-            <a:ext cx="3291480" cy="272520"/>
+              <a:rPr b="0" lang="en-US" sz="2400" spc="-1" strike="noStrike">
+                <a:solidFill>
+                  <a:srgbClr val="ffffff"/>
+                </a:solidFill>
+                <a:latin typeface="Calibri"/>
+              </a:rPr>
+              <a:t>🖥️</a:t>
+            </a:r>
+            <a:endParaRPr b="0" lang="en-US" sz="2400" spc="-1" strike="noStrike">
+              <a:solidFill>
+                <a:srgbClr val="000000"/>
+              </a:solidFill>
+              <a:latin typeface="Arial"/>
+            </a:endParaRPr>
+          </a:p>
+        </p:txBody>
+      </p:sp>
+      <p:sp>
+        <p:nvSpPr>
+          <p:cNvPr id="752" name="TextBox 19"/>
+          <p:cNvSpPr/>
+          <p:nvPr/>
+        </p:nvSpPr>
+        <p:spPr>
+          <a:xfrm>
+            <a:off x="960120" y="4142160"/>
+            <a:ext cx="4754520" cy="303120"/>
           </a:xfrm>
           <a:prstGeom prst="rect">
             <a:avLst/>
@@ -34537,33 +35046,33 @@
               </a:lnSpc>
             </a:pPr>
             <a:r>
-              <a:rPr b="1" lang="en-US" sz="1200" spc="-1" strike="noStrike">
-                <a:solidFill>
-                  <a:srgbClr val="ffffff"/>
-                </a:solidFill>
-                <a:latin typeface="Calibri"/>
-              </a:rPr>
-              <a:t>Аналитика и дашборд</a:t>
-            </a:r>
-            <a:endParaRPr b="0" lang="en-US" sz="1200" spc="-1" strike="noStrike">
-              <a:solidFill>
-                <a:srgbClr val="000000"/>
-              </a:solidFill>
-              <a:latin typeface="Arial"/>
-            </a:endParaRPr>
-          </a:p>
-        </p:txBody>
-      </p:sp>
-      <p:sp>
-        <p:nvSpPr>
-          <p:cNvPr id="752" name="TextBox 19"/>
-          <p:cNvSpPr/>
-          <p:nvPr/>
-        </p:nvSpPr>
-        <p:spPr>
-          <a:xfrm>
-            <a:off x="8138160" y="2386440"/>
-            <a:ext cx="3291480" cy="242280"/>
+              <a:rPr b="1" lang="en-US" sz="1400" spc="-1" strike="noStrike">
+                <a:solidFill>
+                  <a:srgbClr val="f44336"/>
+                </a:solidFill>
+                <a:latin typeface="Calibri"/>
+              </a:rPr>
+              <a:t>GPU-кластер / локальная LLM</a:t>
+            </a:r>
+            <a:endParaRPr b="0" lang="en-US" sz="1400" spc="-1" strike="noStrike">
+              <a:solidFill>
+                <a:srgbClr val="000000"/>
+              </a:solidFill>
+              <a:latin typeface="Arial"/>
+            </a:endParaRPr>
+          </a:p>
+        </p:txBody>
+      </p:sp>
+      <p:sp>
+        <p:nvSpPr>
+          <p:cNvPr id="753" name="TextBox 20"/>
+          <p:cNvSpPr/>
+          <p:nvPr/>
+        </p:nvSpPr>
+        <p:spPr>
+          <a:xfrm>
+            <a:off x="457200" y="4572000"/>
+            <a:ext cx="5303160" cy="592920"/>
           </a:xfrm>
           <a:prstGeom prst="rect">
             <a:avLst/>
@@ -34584,45 +35093,79 @@
             <a:spAutoFit/>
           </a:bodyPr>
           <a:p>
+            <a:r>
+              <a:rPr b="0" lang="en-US" sz="1100" spc="-1" strike="noStrike">
+                <a:solidFill>
+                  <a:srgbClr val="1a1a2e"/>
+                </a:solidFill>
+                <a:latin typeface="Calibri"/>
+              </a:rPr>
+              <a:t>ВНД = конфиденциальные данные, нельзя в облако</a:t>
+            </a:r>
+            <a:endParaRPr b="0" lang="en-US" sz="1100" spc="-1" strike="noStrike">
+              <a:solidFill>
+                <a:srgbClr val="000000"/>
+              </a:solidFill>
+              <a:latin typeface="Arial"/>
+            </a:endParaRPr>
+          </a:p>
+          <a:p>
+            <a:r>
+              <a:rPr b="0" lang="en-US" sz="1100" spc="-1" strike="noStrike">
+                <a:solidFill>
+                  <a:srgbClr val="1a1a2e"/>
+                </a:solidFill>
+                <a:latin typeface="Calibri"/>
+              </a:rPr>
+              <a:t>vLLM + Llama 3 / Mistral на NVIDIA A100</a:t>
+            </a:r>
+            <a:endParaRPr b="0" lang="en-US" sz="1100" spc="-1" strike="noStrike">
+              <a:solidFill>
+                <a:srgbClr val="000000"/>
+              </a:solidFill>
+              <a:latin typeface="Arial"/>
+            </a:endParaRPr>
+          </a:p>
+          <a:p>
             <a:pPr defTabSz="457200">
               <a:lnSpc>
                 <a:spcPct val="100000"/>
               </a:lnSpc>
             </a:pPr>
             <a:r>
-              <a:rPr b="0" lang="en-US" sz="1000" spc="-1" strike="noStrike">
-                <a:solidFill>
-                  <a:srgbClr val="aaccff"/>
-                </a:solidFill>
-                <a:latin typeface="Calibri"/>
-              </a:rPr>
-              <a:t>Dept quality · quarterly trend · maturity F-22 · radar chart</a:t>
-            </a:r>
-            <a:endParaRPr b="0" lang="en-US" sz="1000" spc="-1" strike="noStrike">
-              <a:solidFill>
-                <a:srgbClr val="000000"/>
-              </a:solidFill>
-              <a:latin typeface="Arial"/>
-            </a:endParaRPr>
-          </a:p>
-        </p:txBody>
-      </p:sp>
-      <p:sp>
-        <p:nvSpPr>
-          <p:cNvPr id="753" name="Rectangle 20"/>
-          <p:cNvSpPr/>
-          <p:nvPr/>
-        </p:nvSpPr>
-        <p:spPr>
-          <a:xfrm>
-            <a:off x="320040" y="3429000"/>
-            <a:ext cx="3565800" cy="1691280"/>
+              <a:rPr b="0" lang="en-US" sz="1100" spc="-1" strike="noStrike">
+                <a:solidFill>
+                  <a:srgbClr val="1a1a2e"/>
+                </a:solidFill>
+                <a:latin typeface="Calibri"/>
+              </a:rPr>
+              <a:t>Полная автономность, без rate limits</a:t>
+            </a:r>
+            <a:endParaRPr b="0" lang="en-US" sz="1100" spc="-1" strike="noStrike">
+              <a:solidFill>
+                <a:srgbClr val="000000"/>
+              </a:solidFill>
+              <a:latin typeface="Arial"/>
+            </a:endParaRPr>
+          </a:p>
+        </p:txBody>
+      </p:sp>
+      <p:sp>
+        <p:nvSpPr>
+          <p:cNvPr id="754" name="Rectangle 21"/>
+          <p:cNvSpPr/>
+          <p:nvPr/>
+        </p:nvSpPr>
+        <p:spPr>
+          <a:xfrm>
+            <a:off x="6236280" y="3977640"/>
+            <a:ext cx="5687280" cy="2331360"/>
           </a:xfrm>
           <a:prstGeom prst="rect">
             <a:avLst/>
           </a:prstGeom>
           <a:solidFill>
-            <a:srgbClr val="0d1b3e"/>
+            <a:srgbClr val="ffffff"/>
           </a:solidFill>
           <a:ln>
             <a:noFill/>
@@ -34668,20 +35211,20 @@
       </p:sp>
       <p:sp>
         <p:nvSpPr>
-          <p:cNvPr id="754" name="Rectangle 21"/>
-          <p:cNvSpPr/>
-          <p:nvPr/>
-        </p:nvSpPr>
-        <p:spPr>
-          <a:xfrm>
-            <a:off x="320040" y="3429000"/>
-            <a:ext cx="3565800" cy="72720"/>
+          <p:cNvPr id="755" name="Rectangle 22"/>
+          <p:cNvSpPr/>
+          <p:nvPr/>
+        </p:nvSpPr>
+        <p:spPr>
+          <a:xfrm>
+            <a:off x="6236280" y="3977640"/>
+            <a:ext cx="91080" cy="2331360"/>
           </a:xfrm>
           <a:prstGeom prst="rect">
             <a:avLst/>
           </a:prstGeom>
           <a:solidFill>
-            <a:srgbClr val="e8a838"/>
+            <a:srgbClr val="2e7d32"/>
           </a:solidFill>
           <a:ln>
             <a:noFill/>
@@ -34707,7 +35250,7 @@
           <a:fontRef idx="minor"/>
         </p:style>
         <p:txBody>
-          <a:bodyPr lIns="90000" rIns="90000" tIns="28080" bIns="28080" anchor="ctr">
+          <a:bodyPr lIns="90000" rIns="90000" tIns="45000" bIns="45000" anchor="ctr">
             <a:noAutofit/>
           </a:bodyPr>
           <a:p>
@@ -34727,14 +35270,14 @@
       </p:sp>
       <p:sp>
         <p:nvSpPr>
-          <p:cNvPr id="755" name="TextBox 22"/>
-          <p:cNvSpPr/>
-          <p:nvPr/>
-        </p:nvSpPr>
-        <p:spPr>
-          <a:xfrm>
-            <a:off x="457200" y="3566160"/>
-            <a:ext cx="3291480" cy="288000"/>
+          <p:cNvPr id="756" name="TextBox 23"/>
+          <p:cNvSpPr/>
+          <p:nvPr/>
+        </p:nvSpPr>
+        <p:spPr>
+          <a:xfrm>
+            <a:off x="6419160" y="4114800"/>
+            <a:ext cx="456840" cy="455400"/>
           </a:xfrm>
           <a:prstGeom prst="rect">
             <a:avLst/>
@@ -34761,42 +35304,33 @@
               </a:lnSpc>
             </a:pPr>
             <a:r>
-              <a:rPr b="1" lang="en-US" sz="1300" spc="-1" strike="noStrike">
-                <a:solidFill>
-                  <a:srgbClr val="e8a838"/>
-                </a:solidFill>
-                <a:latin typeface="Calibri"/>
-              </a:rPr>
-              <a:t>⚙️  </a:t>
-            </a:r>
-            <a:r>
-              <a:rPr b="1" lang="en-US" sz="1300" spc="-1" strike="noStrike">
-                <a:solidFill>
-                  <a:srgbClr val="e8a838"/>
-                </a:solidFill>
-                <a:latin typeface="Calibri"/>
-              </a:rPr>
-              <a:t>10%</a:t>
-            </a:r>
-            <a:endParaRPr b="0" lang="en-US" sz="1300" spc="-1" strike="noStrike">
-              <a:solidFill>
-                <a:srgbClr val="000000"/>
-              </a:solidFill>
-              <a:latin typeface="Arial"/>
-            </a:endParaRPr>
-          </a:p>
-        </p:txBody>
-      </p:sp>
-      <p:sp>
-        <p:nvSpPr>
-          <p:cNvPr id="756" name="TextBox 23"/>
-          <p:cNvSpPr/>
-          <p:nvPr/>
-        </p:nvSpPr>
-        <p:spPr>
-          <a:xfrm>
-            <a:off x="457200" y="3940920"/>
-            <a:ext cx="3291480" cy="272520"/>
+              <a:rPr b="0" lang="en-US" sz="2400" spc="-1" strike="noStrike">
+                <a:solidFill>
+                  <a:srgbClr val="ffffff"/>
+                </a:solidFill>
+                <a:latin typeface="Calibri"/>
+              </a:rPr>
+              <a:t>⚡</a:t>
+            </a:r>
+            <a:endParaRPr b="0" lang="en-US" sz="2400" spc="-1" strike="noStrike">
+              <a:solidFill>
+                <a:srgbClr val="000000"/>
+              </a:solidFill>
+              <a:latin typeface="Arial"/>
+            </a:endParaRPr>
+          </a:p>
+        </p:txBody>
+      </p:sp>
+      <p:sp>
+        <p:nvSpPr>
+          <p:cNvPr id="757" name="TextBox 24"/>
+          <p:cNvSpPr/>
+          <p:nvPr/>
+        </p:nvSpPr>
+        <p:spPr>
+          <a:xfrm>
+            <a:off x="6922080" y="4142160"/>
+            <a:ext cx="4754520" cy="303120"/>
           </a:xfrm>
           <a:prstGeom prst="rect">
             <a:avLst/>
@@ -34823,33 +35357,33 @@
               </a:lnSpc>
             </a:pPr>
             <a:r>
-              <a:rPr b="1" lang="en-US" sz="1200" spc="-1" strike="noStrike">
-                <a:solidFill>
-                  <a:srgbClr val="ffffff"/>
-                </a:solidFill>
-                <a:latin typeface="Calibri"/>
-              </a:rPr>
-              <a:t>Архитектура и API</a:t>
-            </a:r>
-            <a:endParaRPr b="0" lang="en-US" sz="1200" spc="-1" strike="noStrike">
-              <a:solidFill>
-                <a:srgbClr val="000000"/>
-              </a:solidFill>
-              <a:latin typeface="Arial"/>
-            </a:endParaRPr>
-          </a:p>
-        </p:txBody>
-      </p:sp>
-      <p:sp>
-        <p:nvSpPr>
-          <p:cNvPr id="757" name="TextBox 24"/>
-          <p:cNvSpPr/>
-          <p:nvPr/>
-        </p:nvSpPr>
-        <p:spPr>
-          <a:xfrm>
-            <a:off x="457200" y="4306680"/>
-            <a:ext cx="3291480" cy="394920"/>
+              <a:rPr b="1" lang="en-US" sz="1400" spc="-1" strike="noStrike">
+                <a:solidFill>
+                  <a:srgbClr val="2e7d32"/>
+                </a:solidFill>
+                <a:latin typeface="Calibri"/>
+              </a:rPr>
+              <a:t>Масштабирование</a:t>
+            </a:r>
+            <a:endParaRPr b="0" lang="en-US" sz="1400" spc="-1" strike="noStrike">
+              <a:solidFill>
+                <a:srgbClr val="000000"/>
+              </a:solidFill>
+              <a:latin typeface="Arial"/>
+            </a:endParaRPr>
+          </a:p>
+        </p:txBody>
+      </p:sp>
+      <p:sp>
+        <p:nvSpPr>
+          <p:cNvPr id="758" name="TextBox 25"/>
+          <p:cNvSpPr/>
+          <p:nvPr/>
+        </p:nvSpPr>
+        <p:spPr>
+          <a:xfrm>
+            <a:off x="6419160" y="4572000"/>
+            <a:ext cx="5303160" cy="592920"/>
           </a:xfrm>
           <a:prstGeom prst="rect">
             <a:avLst/>
@@ -34870,19 +35404,106 @@
             <a:spAutoFit/>
           </a:bodyPr>
           <a:p>
+            <a:r>
+              <a:rPr b="0" lang="en-US" sz="1100" spc="-1" strike="noStrike">
+                <a:solidFill>
+                  <a:srgbClr val="1a1a2e"/>
+                </a:solidFill>
+                <a:latin typeface="Calibri"/>
+              </a:rPr>
+              <a:t>Kubernetes HPA + 3 реплики API</a:t>
+            </a:r>
+            <a:endParaRPr b="0" lang="en-US" sz="1100" spc="-1" strike="noStrike">
+              <a:solidFill>
+                <a:srgbClr val="000000"/>
+              </a:solidFill>
+              <a:latin typeface="Arial"/>
+            </a:endParaRPr>
+          </a:p>
+          <a:p>
+            <a:r>
+              <a:rPr b="0" lang="en-US" sz="1100" spc="-1" strike="noStrike">
+                <a:solidFill>
+                  <a:srgbClr val="1a1a2e"/>
+                </a:solidFill>
+                <a:latin typeface="Calibri"/>
+              </a:rPr>
+              <a:t>Redis: rate limiting + кеш + Celery очередь</a:t>
+            </a:r>
+            <a:endParaRPr b="0" lang="en-US" sz="1100" spc="-1" strike="noStrike">
+              <a:solidFill>
+                <a:srgbClr val="000000"/>
+              </a:solidFill>
+              <a:latin typeface="Arial"/>
+            </a:endParaRPr>
+          </a:p>
+          <a:p>
             <a:pPr defTabSz="457200">
               <a:lnSpc>
                 <a:spcPct val="100000"/>
               </a:lnSpc>
             </a:pPr>
             <a:r>
+              <a:rPr b="0" lang="en-US" sz="1100" spc="-1" strike="noStrike">
+                <a:solidFill>
+                  <a:srgbClr val="1a1a2e"/>
+                </a:solidFill>
+                <a:latin typeface="Calibri"/>
+              </a:rPr>
+              <a:t>Gunicorn + N workers вместо 1 uvicorn</a:t>
+            </a:r>
+            <a:endParaRPr b="0" lang="en-US" sz="1100" spc="-1" strike="noStrike">
+              <a:solidFill>
+                <a:srgbClr val="000000"/>
+              </a:solidFill>
+              <a:latin typeface="Arial"/>
+            </a:endParaRPr>
+          </a:p>
+        </p:txBody>
+      </p:sp>
+      <p:sp>
+        <p:nvSpPr>
+          <p:cNvPr id="759" name="TextBox 26"/>
+          <p:cNvSpPr/>
+          <p:nvPr/>
+        </p:nvSpPr>
+        <p:spPr>
+          <a:xfrm>
+            <a:off x="11064240" y="6492240"/>
+            <a:ext cx="1005480" cy="242280"/>
+          </a:xfrm>
+          <a:prstGeom prst="rect">
+            <a:avLst/>
+          </a:prstGeom>
+          <a:noFill/>
+          <a:ln w="0">
+            <a:noFill/>
+          </a:ln>
+        </p:spPr>
+        <p:style>
+          <a:lnRef idx="0"/>
+          <a:fillRef idx="0"/>
+          <a:effectRef idx="0"/>
+          <a:fontRef idx="minor"/>
+        </p:style>
+        <p:txBody>
+          <a:bodyPr lIns="90000" rIns="90000" tIns="45000" bIns="45000" anchor="t">
+            <a:spAutoFit/>
+          </a:bodyPr>
+          <a:p>
+            <a:pPr algn="r" defTabSz="457200">
+              <a:lnSpc>
+                <a:spcPct val="100000"/>
+              </a:lnSpc>
+            </a:pPr>
+            <a:r>
               <a:rPr b="0" lang="en-US" sz="1000" spc="-1" strike="noStrike">
                 <a:solidFill>
-                  <a:srgbClr val="aaccff"/>
-                </a:solidFill>
-                <a:latin typeface="Calibri"/>
-              </a:rPr>
-              <a:t>FastAPI · OpenAPI /docs · Docker Compose · Alembic · Pydantic v2</a:t>
+                  <a:srgbClr val="aaaaaa"/>
+                </a:solidFill>
+                <a:latin typeface="Calibri"/>
+              </a:rPr>
+              <a:t>20 / 21</a:t>
             </a:r>
             <a:endParaRPr b="0" lang="en-US" sz="1000" spc="-1" strike="noStrike">
               <a:solidFill>
@@ -34893,22 +35514,52 @@
           </a:p>
         </p:txBody>
       </p:sp>
-      <p:sp>
-        <p:nvSpPr>
-          <p:cNvPr id="758" name="Rectangle 25"/>
-          <p:cNvSpPr/>
-          <p:nvPr/>
-        </p:nvSpPr>
-        <p:spPr>
-          <a:xfrm>
-            <a:off x="4160520" y="3429000"/>
-            <a:ext cx="3565800" cy="1691280"/>
+    </p:spTree>
+  </p:cSld>
+  <mc:AlternateContent>
+    <mc:Choice Requires="p14">
+      <p:transition spd="slow" p14:dur="2000"/>
+    </mc:Choice>
+    <mc:Fallback>
+      <p:transition spd="slow"/>
+    </mc:Fallback>
+  </mc:AlternateContent>
+</p:sld>
+</file>
+
+<file path=ppt/slides/slide21.xml><?xml version="1.0" encoding="utf-8"?>
+<p:sld xmlns:a="http://schemas.openxmlformats.org/drawingml/2006/main" xmlns:p="http://schemas.openxmlformats.org/presentationml/2006/main" xmlns:r="http://schemas.openxmlformats.org/officeDocument/2006/relationships" xmlns:p14="http://schemas.microsoft.com/office/powerpoint/2010/main" xmlns:p15="http://schemas.microsoft.com/office/powerpoint/2012/main" xmlns:mc="http://schemas.openxmlformats.org/markup-compatibility/2006">
+  <p:cSld>
+    <p:spTree>
+      <p:nvGrpSpPr>
+        <p:cNvPr id="1" name=""/>
+        <p:cNvGrpSpPr/>
+        <p:nvPr/>
+      </p:nvGrpSpPr>
+      <p:grpSpPr>
+        <a:xfrm>
+          <a:off x="0" y="0"/>
+          <a:ext cx="0" cy="0"/>
+          <a:chOff x="0" y="0"/>
+          <a:chExt cx="0" cy="0"/>
+        </a:xfrm>
+      </p:grpSpPr>
+      <p:sp>
+        <p:nvSpPr>
+          <p:cNvPr id="760" name="Rectangle 1"/>
+          <p:cNvSpPr/>
+          <p:nvPr/>
+        </p:nvSpPr>
+        <p:spPr>
+          <a:xfrm>
+            <a:off x="0" y="0"/>
+            <a:ext cx="12188520" cy="6857640"/>
           </a:xfrm>
           <a:prstGeom prst="rect">
             <a:avLst/>
           </a:prstGeom>
           <a:solidFill>
-            <a:srgbClr val="0d1b3e"/>
+            <a:srgbClr val="1a3264"/>
           </a:solidFill>
           <a:ln>
             <a:noFill/>
@@ -34954,14 +35605,14 @@
       </p:sp>
       <p:sp>
         <p:nvSpPr>
-          <p:cNvPr id="759" name="Rectangle 26"/>
-          <p:cNvSpPr/>
-          <p:nvPr/>
-        </p:nvSpPr>
-        <p:spPr>
-          <a:xfrm>
-            <a:off x="4160520" y="3429000"/>
-            <a:ext cx="3565800" cy="72720"/>
+          <p:cNvPr id="761" name="Rectangle 2"/>
+          <p:cNvSpPr/>
+          <p:nvPr/>
+        </p:nvSpPr>
+        <p:spPr>
+          <a:xfrm>
+            <a:off x="360" y="5486400"/>
+            <a:ext cx="12188520" cy="109440"/>
           </a:xfrm>
           <a:prstGeom prst="rect">
             <a:avLst/>
@@ -34993,7 +35644,7 @@
           <a:fontRef idx="minor"/>
         </p:style>
         <p:txBody>
-          <a:bodyPr lIns="90000" rIns="90000" tIns="28080" bIns="28080" anchor="ctr">
+          <a:bodyPr lIns="90000" rIns="90000" tIns="45000" bIns="45000" anchor="ctr">
             <a:noAutofit/>
           </a:bodyPr>
           <a:p>
@@ -35013,14 +35664,73 @@
       </p:sp>
       <p:sp>
         <p:nvSpPr>
-          <p:cNvPr id="760" name="TextBox 27"/>
-          <p:cNvSpPr/>
-          <p:nvPr/>
-        </p:nvSpPr>
-        <p:spPr>
-          <a:xfrm>
-            <a:off x="4297680" y="3566160"/>
-            <a:ext cx="3291480" cy="288000"/>
+          <p:cNvPr id="762" name="Rectangle 3"/>
+          <p:cNvSpPr/>
+          <p:nvPr/>
+        </p:nvSpPr>
+        <p:spPr>
+          <a:xfrm>
+            <a:off x="0" y="0"/>
+            <a:ext cx="164160" cy="6857640"/>
+          </a:xfrm>
+          <a:prstGeom prst="rect">
+            <a:avLst/>
+          </a:prstGeom>
+          <a:solidFill>
+            <a:srgbClr val="e8a838"/>
+          </a:solidFill>
+          <a:ln>
+            <a:noFill/>
+          </a:ln>
+          <a:effectLst>
+            <a:outerShdw blurRad="39960" dir="5400000" dist="23040" rotWithShape="0">
+              <a:srgbClr val="000000">
+                <a:alpha val="35000"/>
+              </a:srgbClr>
+            </a:outerShdw>
+          </a:effectLst>
+        </p:spPr>
+        <p:style>
+          <a:lnRef idx="1">
+            <a:schemeClr val="accent1"/>
+          </a:lnRef>
+          <a:fillRef idx="3">
+            <a:schemeClr val="accent1"/>
+          </a:fillRef>
+          <a:effectRef idx="2">
+            <a:schemeClr val="accent1"/>
+          </a:effectRef>
+          <a:fontRef idx="minor"/>
+        </p:style>
+        <p:txBody>
+          <a:bodyPr lIns="90000" rIns="90000" tIns="45000" bIns="45000" anchor="ctr">
+            <a:noAutofit/>
+          </a:bodyPr>
+          <a:p>
+            <a:pPr algn="ctr" defTabSz="457200">
+              <a:lnSpc>
+                <a:spcPct val="100000"/>
+              </a:lnSpc>
+            </a:pPr>
+            <a:endParaRPr b="0" lang="en-US" sz="1800" spc="-1" strike="noStrike">
+              <a:solidFill>
+                <a:schemeClr val="lt1"/>
+              </a:solidFill>
+              <a:latin typeface="Calibri"/>
+            </a:endParaRPr>
+          </a:p>
+        </p:txBody>
+      </p:sp>
+      <p:sp>
+        <p:nvSpPr>
+          <p:cNvPr id="763" name="TextBox 4"/>
+          <p:cNvSpPr/>
+          <p:nvPr/>
+        </p:nvSpPr>
+        <p:spPr>
+          <a:xfrm>
+            <a:off x="457200" y="548640"/>
+            <a:ext cx="11274120" cy="699120"/>
           </a:xfrm>
           <a:prstGeom prst="rect">
             <a:avLst/>
@@ -35041,48 +35751,157 @@
             <a:spAutoFit/>
           </a:bodyPr>
           <a:p>
-            <a:pPr defTabSz="457200">
-              <a:lnSpc>
-                <a:spcPct val="100000"/>
-              </a:lnSpc>
-            </a:pPr>
-            <a:r>
-              <a:rPr b="1" lang="en-US" sz="1300" spc="-1" strike="noStrike">
-                <a:solidFill>
-                  <a:srgbClr val="e8a838"/>
-                </a:solidFill>
-                <a:latin typeface="Calibri"/>
-              </a:rPr>
-              <a:t>💻  </a:t>
-            </a:r>
-            <a:r>
-              <a:rPr b="1" lang="en-US" sz="1300" spc="-1" strike="noStrike">
-                <a:solidFill>
-                  <a:srgbClr val="e8a838"/>
-                </a:solidFill>
-                <a:latin typeface="Calibri"/>
-              </a:rPr>
-              <a:t>15%</a:t>
-            </a:r>
-            <a:endParaRPr b="0" lang="en-US" sz="1300" spc="-1" strike="noStrike">
-              <a:solidFill>
-                <a:srgbClr val="000000"/>
-              </a:solidFill>
-              <a:latin typeface="Arial"/>
-            </a:endParaRPr>
-          </a:p>
-        </p:txBody>
-      </p:sp>
-      <p:sp>
-        <p:nvSpPr>
-          <p:cNvPr id="761" name="TextBox 28"/>
-          <p:cNvSpPr/>
-          <p:nvPr/>
-        </p:nvSpPr>
-        <p:spPr>
-          <a:xfrm>
-            <a:off x="4297680" y="3940920"/>
-            <a:ext cx="3291480" cy="272520"/>
+            <a:pPr algn="ctr" defTabSz="457200">
+              <a:lnSpc>
+                <a:spcPct val="100000"/>
+              </a:lnSpc>
+            </a:pPr>
+            <a:r>
+              <a:rPr b="1" lang="en-US" sz="4000" spc="-1" strike="noStrike">
+                <a:solidFill>
+                  <a:srgbClr val="ffffff"/>
+                </a:solidFill>
+                <a:latin typeface="Calibri"/>
+              </a:rPr>
+              <a:t>Спасибо за внимание</a:t>
+            </a:r>
+            <a:endParaRPr b="0" lang="en-US" sz="4000" spc="-1" strike="noStrike">
+              <a:solidFill>
+                <a:srgbClr val="000000"/>
+              </a:solidFill>
+              <a:latin typeface="Arial"/>
+            </a:endParaRPr>
+          </a:p>
+        </p:txBody>
+      </p:sp>
+      <p:sp>
+        <p:nvSpPr>
+          <p:cNvPr id="764" name="Rectangle 5"/>
+          <p:cNvSpPr/>
+          <p:nvPr/>
+        </p:nvSpPr>
+        <p:spPr>
+          <a:xfrm>
+            <a:off x="320040" y="1508760"/>
+            <a:ext cx="3565800" cy="1691280"/>
+          </a:xfrm>
+          <a:prstGeom prst="rect">
+            <a:avLst/>
+          </a:prstGeom>
+          <a:solidFill>
+            <a:srgbClr val="0d1b3e"/>
+          </a:solidFill>
+          <a:ln>
+            <a:noFill/>
+          </a:ln>
+          <a:effectLst>
+            <a:outerShdw blurRad="39960" dir="5400000" dist="23040" rotWithShape="0">
+              <a:srgbClr val="000000">
+                <a:alpha val="35000"/>
+              </a:srgbClr>
+            </a:outerShdw>
+          </a:effectLst>
+        </p:spPr>
+        <p:style>
+          <a:lnRef idx="1">
+            <a:schemeClr val="accent1"/>
+          </a:lnRef>
+          <a:fillRef idx="3">
+            <a:schemeClr val="accent1"/>
+          </a:fillRef>
+          <a:effectRef idx="2">
+            <a:schemeClr val="accent1"/>
+          </a:effectRef>
+          <a:fontRef idx="minor"/>
+        </p:style>
+        <p:txBody>
+          <a:bodyPr lIns="90000" rIns="90000" tIns="45000" bIns="45000" anchor="ctr">
+            <a:noAutofit/>
+          </a:bodyPr>
+          <a:p>
+            <a:pPr algn="ctr" defTabSz="457200">
+              <a:lnSpc>
+                <a:spcPct val="100000"/>
+              </a:lnSpc>
+            </a:pPr>
+            <a:endParaRPr b="0" lang="en-US" sz="1800" spc="-1" strike="noStrike">
+              <a:solidFill>
+                <a:schemeClr val="lt1"/>
+              </a:solidFill>
+              <a:latin typeface="Calibri"/>
+            </a:endParaRPr>
+          </a:p>
+        </p:txBody>
+      </p:sp>
+      <p:sp>
+        <p:nvSpPr>
+          <p:cNvPr id="765" name="Rectangle 6"/>
+          <p:cNvSpPr/>
+          <p:nvPr/>
+        </p:nvSpPr>
+        <p:spPr>
+          <a:xfrm>
+            <a:off x="320040" y="1508760"/>
+            <a:ext cx="3565800" cy="72720"/>
+          </a:xfrm>
+          <a:prstGeom prst="rect">
+            <a:avLst/>
+          </a:prstGeom>
+          <a:solidFill>
+            <a:srgbClr val="e8a838"/>
+          </a:solidFill>
+          <a:ln>
+            <a:noFill/>
+          </a:ln>
+          <a:effectLst>
+            <a:outerShdw blurRad="39960" dir="5400000" dist="23040" rotWithShape="0">
+              <a:srgbClr val="000000">
+                <a:alpha val="35000"/>
+              </a:srgbClr>
+            </a:outerShdw>
+          </a:effectLst>
+        </p:spPr>
+        <p:style>
+          <a:lnRef idx="1">
+            <a:schemeClr val="accent1"/>
+          </a:lnRef>
+          <a:fillRef idx="3">
+            <a:schemeClr val="accent1"/>
+          </a:fillRef>
+          <a:effectRef idx="2">
+            <a:schemeClr val="accent1"/>
+          </a:effectRef>
+          <a:fontRef idx="minor"/>
+        </p:style>
+        <p:txBody>
+          <a:bodyPr lIns="90000" rIns="90000" tIns="28080" bIns="28080" anchor="ctr">
+            <a:noAutofit/>
+          </a:bodyPr>
+          <a:p>
+            <a:pPr algn="ctr" defTabSz="457200">
+              <a:lnSpc>
+                <a:spcPct val="100000"/>
+              </a:lnSpc>
+            </a:pPr>
+            <a:endParaRPr b="0" lang="en-US" sz="1800" spc="-1" strike="noStrike">
+              <a:solidFill>
+                <a:schemeClr val="lt1"/>
+              </a:solidFill>
+              <a:latin typeface="Calibri"/>
+            </a:endParaRPr>
+          </a:p>
+        </p:txBody>
+      </p:sp>
+      <p:sp>
+        <p:nvSpPr>
+          <p:cNvPr id="766" name="TextBox 7"/>
+          <p:cNvSpPr/>
+          <p:nvPr/>
+        </p:nvSpPr>
+        <p:spPr>
+          <a:xfrm>
+            <a:off x="457200" y="1645920"/>
+            <a:ext cx="3291480" cy="288000"/>
           </a:xfrm>
           <a:prstGeom prst="rect">
             <a:avLst/>
@@ -35109,33 +35928,42 @@
               </a:lnSpc>
             </a:pPr>
             <a:r>
-              <a:rPr b="1" lang="en-US" sz="1200" spc="-1" strike="noStrike">
-                <a:solidFill>
-                  <a:srgbClr val="ffffff"/>
-                </a:solidFill>
-                <a:latin typeface="Calibri"/>
-              </a:rPr>
-              <a:t>UX интерфейса</a:t>
-            </a:r>
-            <a:endParaRPr b="0" lang="en-US" sz="1200" spc="-1" strike="noStrike">
-              <a:solidFill>
-                <a:srgbClr val="000000"/>
-              </a:solidFill>
-              <a:latin typeface="Arial"/>
-            </a:endParaRPr>
-          </a:p>
-        </p:txBody>
-      </p:sp>
-      <p:sp>
-        <p:nvSpPr>
-          <p:cNvPr id="762" name="TextBox 29"/>
-          <p:cNvSpPr/>
-          <p:nvPr/>
-        </p:nvSpPr>
-        <p:spPr>
-          <a:xfrm>
-            <a:off x="4297680" y="4306680"/>
-            <a:ext cx="3291480" cy="242280"/>
+              <a:rPr b="1" lang="en-US" sz="1300" spc="-1" strike="noStrike">
+                <a:solidFill>
+                  <a:srgbClr val="e8a838"/>
+                </a:solidFill>
+                <a:latin typeface="Calibri"/>
+              </a:rPr>
+              <a:t>🎯  </a:t>
+            </a:r>
+            <a:r>
+              <a:rPr b="1" lang="en-US" sz="1300" spc="-1" strike="noStrike">
+                <a:solidFill>
+                  <a:srgbClr val="e8a838"/>
+                </a:solidFill>
+                <a:latin typeface="Calibri"/>
+              </a:rPr>
+              <a:t>25% + 25%</a:t>
+            </a:r>
+            <a:endParaRPr b="0" lang="en-US" sz="1300" spc="-1" strike="noStrike">
+              <a:solidFill>
+                <a:srgbClr val="000000"/>
+              </a:solidFill>
+              <a:latin typeface="Arial"/>
+            </a:endParaRPr>
+          </a:p>
+        </p:txBody>
+      </p:sp>
+      <p:sp>
+        <p:nvSpPr>
+          <p:cNvPr id="767" name="TextBox 8"/>
+          <p:cNvSpPr/>
+          <p:nvPr/>
+        </p:nvSpPr>
+        <p:spPr>
+          <a:xfrm>
+            <a:off x="457200" y="2020680"/>
+            <a:ext cx="3291480" cy="272520"/>
           </a:xfrm>
           <a:prstGeom prst="rect">
             <a:avLst/>
@@ -35162,33 +35990,33 @@
               </a:lnSpc>
             </a:pPr>
             <a:r>
-              <a:rPr b="0" lang="en-US" sz="1000" spc="-1" strike="noStrike">
-                <a:solidFill>
-                  <a:srgbClr val="aaccff"/>
-                </a:solidFill>
-                <a:latin typeface="Calibri"/>
-              </a:rPr>
-              <a:t>React 18 · MUI · 4 страницы · progress bars · alert banners</a:t>
-            </a:r>
-            <a:endParaRPr b="0" lang="en-US" sz="1000" spc="-1" strike="noStrike">
-              <a:solidFill>
-                <a:srgbClr val="000000"/>
-              </a:solidFill>
-              <a:latin typeface="Arial"/>
-            </a:endParaRPr>
-          </a:p>
-        </p:txBody>
-      </p:sp>
-      <p:sp>
-        <p:nvSpPr>
-          <p:cNvPr id="763" name="TextBox 30"/>
-          <p:cNvSpPr/>
-          <p:nvPr/>
-        </p:nvSpPr>
-        <p:spPr>
-          <a:xfrm>
-            <a:off x="457200" y="6309360"/>
-            <a:ext cx="11274120" cy="272520"/>
+              <a:rPr b="1" lang="en-US" sz="1200" spc="-1" strike="noStrike">
+                <a:solidFill>
+                  <a:srgbClr val="ffffff"/>
+                </a:solidFill>
+                <a:latin typeface="Calibri"/>
+              </a:rPr>
+              <a:t>SMART-оценка + AI-генерация</a:t>
+            </a:r>
+            <a:endParaRPr b="0" lang="en-US" sz="1200" spc="-1" strike="noStrike">
+              <a:solidFill>
+                <a:srgbClr val="000000"/>
+              </a:solidFill>
+              <a:latin typeface="Arial"/>
+            </a:endParaRPr>
+          </a:p>
+        </p:txBody>
+      </p:sp>
+      <p:sp>
+        <p:nvSpPr>
+          <p:cNvPr id="768" name="TextBox 9"/>
+          <p:cNvSpPr/>
+          <p:nvPr/>
+        </p:nvSpPr>
+        <p:spPr>
+          <a:xfrm>
+            <a:off x="457200" y="2386440"/>
+            <a:ext cx="3291480" cy="242280"/>
           </a:xfrm>
           <a:prstGeom prst="rect">
             <a:avLst/>
@@ -35209,39 +36037,157 @@
             <a:spAutoFit/>
           </a:bodyPr>
           <a:p>
+            <a:pPr defTabSz="457200">
+              <a:lnSpc>
+                <a:spcPct val="100000"/>
+              </a:lnSpc>
+            </a:pPr>
+            <a:r>
+              <a:rPr b="0" lang="en-US" sz="1000" spc="-1" strike="noStrike">
+                <a:solidFill>
+                  <a:srgbClr val="aaccff"/>
+                </a:solidFill>
+                <a:latin typeface="Calibri"/>
+              </a:rPr>
+              <a:t>Gemini Flash · 5 критериев · goal_type · strategic_alignment</a:t>
+            </a:r>
+            <a:endParaRPr b="0" lang="en-US" sz="1000" spc="-1" strike="noStrike">
+              <a:solidFill>
+                <a:srgbClr val="000000"/>
+              </a:solidFill>
+              <a:latin typeface="Arial"/>
+            </a:endParaRPr>
+          </a:p>
+        </p:txBody>
+      </p:sp>
+      <p:sp>
+        <p:nvSpPr>
+          <p:cNvPr id="769" name="Rectangle 10"/>
+          <p:cNvSpPr/>
+          <p:nvPr/>
+        </p:nvSpPr>
+        <p:spPr>
+          <a:xfrm>
+            <a:off x="4160520" y="1508760"/>
+            <a:ext cx="3565800" cy="1691280"/>
+          </a:xfrm>
+          <a:prstGeom prst="rect">
+            <a:avLst/>
+          </a:prstGeom>
+          <a:solidFill>
+            <a:srgbClr val="0d1b3e"/>
+          </a:solidFill>
+          <a:ln>
+            <a:noFill/>
+          </a:ln>
+          <a:effectLst>
+            <a:outerShdw blurRad="39960" dir="5400000" dist="23040" rotWithShape="0">
+              <a:srgbClr val="000000">
+                <a:alpha val="35000"/>
+              </a:srgbClr>
+            </a:outerShdw>
+          </a:effectLst>
+        </p:spPr>
+        <p:style>
+          <a:lnRef idx="1">
+            <a:schemeClr val="accent1"/>
+          </a:lnRef>
+          <a:fillRef idx="3">
+            <a:schemeClr val="accent1"/>
+          </a:fillRef>
+          <a:effectRef idx="2">
+            <a:schemeClr val="accent1"/>
+          </a:effectRef>
+          <a:fontRef idx="minor"/>
+        </p:style>
+        <p:txBody>
+          <a:bodyPr lIns="90000" rIns="90000" tIns="45000" bIns="45000" anchor="ctr">
+            <a:noAutofit/>
+          </a:bodyPr>
+          <a:p>
             <a:pPr algn="ctr" defTabSz="457200">
               <a:lnSpc>
                 <a:spcPct val="100000"/>
               </a:lnSpc>
             </a:pPr>
-            <a:r>
-              <a:rPr b="0" i="1" lang="en-US" sz="1200" spc="-1" strike="noStrike">
-                <a:solidFill>
-                  <a:srgbClr val="99bbee"/>
-                </a:solidFill>
-                <a:latin typeface="Calibri"/>
-              </a:rPr>
-              <a:t>Frontend: http://89.207.255.254:3000   ·   API: http://89.207.255.254:8001/docs</a:t>
-            </a:r>
-            <a:endParaRPr b="0" lang="en-US" sz="1200" spc="-1" strike="noStrike">
-              <a:solidFill>
-                <a:srgbClr val="000000"/>
-              </a:solidFill>
-              <a:latin typeface="Arial"/>
-            </a:endParaRPr>
-          </a:p>
-        </p:txBody>
-      </p:sp>
-      <p:sp>
-        <p:nvSpPr>
-          <p:cNvPr id="764" name="TextBox 31"/>
-          <p:cNvSpPr/>
-          <p:nvPr/>
-        </p:nvSpPr>
-        <p:spPr>
-          <a:xfrm>
-            <a:off x="11064240" y="6492240"/>
-            <a:ext cx="1005480" cy="242280"/>
+            <a:endParaRPr b="0" lang="en-US" sz="1800" spc="-1" strike="noStrike">
+              <a:solidFill>
+                <a:schemeClr val="lt1"/>
+              </a:solidFill>
+              <a:latin typeface="Calibri"/>
+            </a:endParaRPr>
+          </a:p>
+        </p:txBody>
+      </p:sp>
+      <p:sp>
+        <p:nvSpPr>
+          <p:cNvPr id="770" name="Rectangle 11"/>
+          <p:cNvSpPr/>
+          <p:nvPr/>
+        </p:nvSpPr>
+        <p:spPr>
+          <a:xfrm>
+            <a:off x="4160520" y="1508760"/>
+            <a:ext cx="3565800" cy="72720"/>
+          </a:xfrm>
+          <a:prstGeom prst="rect">
+            <a:avLst/>
+          </a:prstGeom>
+          <a:solidFill>
+            <a:srgbClr val="e8a838"/>
+          </a:solidFill>
+          <a:ln>
+            <a:noFill/>
+          </a:ln>
+          <a:effectLst>
+            <a:outerShdw blurRad="39960" dir="5400000" dist="23040" rotWithShape="0">
+              <a:srgbClr val="000000">
+                <a:alpha val="35000"/>
+              </a:srgbClr>
+            </a:outerShdw>
+          </a:effectLst>
+        </p:spPr>
+        <p:style>
+          <a:lnRef idx="1">
+            <a:schemeClr val="accent1"/>
+          </a:lnRef>
+          <a:fillRef idx="3">
+            <a:schemeClr val="accent1"/>
+          </a:fillRef>
+          <a:effectRef idx="2">
+            <a:schemeClr val="accent1"/>
+          </a:effectRef>
+          <a:fontRef idx="minor"/>
+        </p:style>
+        <p:txBody>
+          <a:bodyPr lIns="90000" rIns="90000" tIns="28080" bIns="28080" anchor="ctr">
+            <a:noAutofit/>
+          </a:bodyPr>
+          <a:p>
+            <a:pPr algn="ctr" defTabSz="457200">
+              <a:lnSpc>
+                <a:spcPct val="100000"/>
+              </a:lnSpc>
+            </a:pPr>
+            <a:endParaRPr b="0" lang="en-US" sz="1800" spc="-1" strike="noStrike">
+              <a:solidFill>
+                <a:schemeClr val="lt1"/>
+              </a:solidFill>
+              <a:latin typeface="Calibri"/>
+            </a:endParaRPr>
+          </a:p>
+        </p:txBody>
+      </p:sp>
+      <p:sp>
+        <p:nvSpPr>
+          <p:cNvPr id="771" name="TextBox 12"/>
+          <p:cNvSpPr/>
+          <p:nvPr/>
+        </p:nvSpPr>
+        <p:spPr>
+          <a:xfrm>
+            <a:off x="4297680" y="1645920"/>
+            <a:ext cx="3291480" cy="288000"/>
           </a:xfrm>
           <a:prstGeom prst="rect">
             <a:avLst/>
@@ -35262,6 +36208,1085 @@
             <a:spAutoFit/>
           </a:bodyPr>
           <a:p>
+            <a:pPr defTabSz="457200">
+              <a:lnSpc>
+                <a:spcPct val="100000"/>
+              </a:lnSpc>
+            </a:pPr>
+            <a:r>
+              <a:rPr b="1" lang="en-US" sz="1300" spc="-1" strike="noStrike">
+                <a:solidFill>
+                  <a:srgbClr val="e8a838"/>
+                </a:solidFill>
+                <a:latin typeface="Calibri"/>
+              </a:rPr>
+              <a:t>🔍  </a:t>
+            </a:r>
+            <a:r>
+              <a:rPr b="1" lang="en-US" sz="1300" spc="-1" strike="noStrike">
+                <a:solidFill>
+                  <a:srgbClr val="e8a838"/>
+                </a:solidFill>
+                <a:latin typeface="Calibri"/>
+              </a:rPr>
+              <a:t>15%</a:t>
+            </a:r>
+            <a:endParaRPr b="0" lang="en-US" sz="1300" spc="-1" strike="noStrike">
+              <a:solidFill>
+                <a:srgbClr val="000000"/>
+              </a:solidFill>
+              <a:latin typeface="Arial"/>
+            </a:endParaRPr>
+          </a:p>
+        </p:txBody>
+      </p:sp>
+      <p:sp>
+        <p:nvSpPr>
+          <p:cNvPr id="772" name="TextBox 13"/>
+          <p:cNvSpPr/>
+          <p:nvPr/>
+        </p:nvSpPr>
+        <p:spPr>
+          <a:xfrm>
+            <a:off x="4297680" y="2020680"/>
+            <a:ext cx="3291480" cy="272520"/>
+          </a:xfrm>
+          <a:prstGeom prst="rect">
+            <a:avLst/>
+          </a:prstGeom>
+          <a:noFill/>
+          <a:ln w="0">
+            <a:noFill/>
+          </a:ln>
+        </p:spPr>
+        <p:style>
+          <a:lnRef idx="0"/>
+          <a:fillRef idx="0"/>
+          <a:effectRef idx="0"/>
+          <a:fontRef idx="minor"/>
+        </p:style>
+        <p:txBody>
+          <a:bodyPr lIns="90000" rIns="90000" tIns="45000" bIns="45000" anchor="t">
+            <a:spAutoFit/>
+          </a:bodyPr>
+          <a:p>
+            <a:pPr defTabSz="457200">
+              <a:lnSpc>
+                <a:spcPct val="100000"/>
+              </a:lnSpc>
+            </a:pPr>
+            <a:r>
+              <a:rPr b="1" lang="en-US" sz="1200" spc="-1" strike="noStrike">
+                <a:solidFill>
+                  <a:srgbClr val="ffffff"/>
+                </a:solidFill>
+                <a:latin typeface="Calibri"/>
+              </a:rPr>
+              <a:t>RAG-пайплайн</a:t>
+            </a:r>
+            <a:endParaRPr b="0" lang="en-US" sz="1200" spc="-1" strike="noStrike">
+              <a:solidFill>
+                <a:srgbClr val="000000"/>
+              </a:solidFill>
+              <a:latin typeface="Arial"/>
+            </a:endParaRPr>
+          </a:p>
+        </p:txBody>
+      </p:sp>
+      <p:sp>
+        <p:nvSpPr>
+          <p:cNvPr id="773" name="TextBox 14"/>
+          <p:cNvSpPr/>
+          <p:nvPr/>
+        </p:nvSpPr>
+        <p:spPr>
+          <a:xfrm>
+            <a:off x="4297680" y="2386440"/>
+            <a:ext cx="3291480" cy="242280"/>
+          </a:xfrm>
+          <a:prstGeom prst="rect">
+            <a:avLst/>
+          </a:prstGeom>
+          <a:noFill/>
+          <a:ln w="0">
+            <a:noFill/>
+          </a:ln>
+        </p:spPr>
+        <p:style>
+          <a:lnRef idx="0"/>
+          <a:fillRef idx="0"/>
+          <a:effectRef idx="0"/>
+          <a:fontRef idx="minor"/>
+        </p:style>
+        <p:txBody>
+          <a:bodyPr lIns="90000" rIns="90000" tIns="45000" bIns="45000" anchor="t">
+            <a:spAutoFit/>
+          </a:bodyPr>
+          <a:p>
+            <a:pPr defTabSz="457200">
+              <a:lnSpc>
+                <a:spcPct val="100000"/>
+              </a:lnSpc>
+            </a:pPr>
+            <a:r>
+              <a:rPr b="0" lang="en-US" sz="1000" spc="-1" strike="noStrike">
+                <a:solidFill>
+                  <a:srgbClr val="aaccff"/>
+                </a:solidFill>
+                <a:latin typeface="Calibri"/>
+              </a:rPr>
+              <a:t>Qdrant · 160 ВНД · 412 чанков · cosine · source grounding</a:t>
+            </a:r>
+            <a:endParaRPr b="0" lang="en-US" sz="1000" spc="-1" strike="noStrike">
+              <a:solidFill>
+                <a:srgbClr val="000000"/>
+              </a:solidFill>
+              <a:latin typeface="Arial"/>
+            </a:endParaRPr>
+          </a:p>
+        </p:txBody>
+      </p:sp>
+      <p:sp>
+        <p:nvSpPr>
+          <p:cNvPr id="774" name="Rectangle 15"/>
+          <p:cNvSpPr/>
+          <p:nvPr/>
+        </p:nvSpPr>
+        <p:spPr>
+          <a:xfrm>
+            <a:off x="8001000" y="1508760"/>
+            <a:ext cx="3565800" cy="1691280"/>
+          </a:xfrm>
+          <a:prstGeom prst="rect">
+            <a:avLst/>
+          </a:prstGeom>
+          <a:solidFill>
+            <a:srgbClr val="0d1b3e"/>
+          </a:solidFill>
+          <a:ln>
+            <a:noFill/>
+          </a:ln>
+          <a:effectLst>
+            <a:outerShdw blurRad="39960" dir="5400000" dist="23040" rotWithShape="0">
+              <a:srgbClr val="000000">
+                <a:alpha val="35000"/>
+              </a:srgbClr>
+            </a:outerShdw>
+          </a:effectLst>
+        </p:spPr>
+        <p:style>
+          <a:lnRef idx="1">
+            <a:schemeClr val="accent1"/>
+          </a:lnRef>
+          <a:fillRef idx="3">
+            <a:schemeClr val="accent1"/>
+          </a:fillRef>
+          <a:effectRef idx="2">
+            <a:schemeClr val="accent1"/>
+          </a:effectRef>
+          <a:fontRef idx="minor"/>
+        </p:style>
+        <p:txBody>
+          <a:bodyPr lIns="90000" rIns="90000" tIns="45000" bIns="45000" anchor="ctr">
+            <a:noAutofit/>
+          </a:bodyPr>
+          <a:p>
+            <a:pPr algn="ctr" defTabSz="457200">
+              <a:lnSpc>
+                <a:spcPct val="100000"/>
+              </a:lnSpc>
+            </a:pPr>
+            <a:endParaRPr b="0" lang="en-US" sz="1800" spc="-1" strike="noStrike">
+              <a:solidFill>
+                <a:schemeClr val="lt1"/>
+              </a:solidFill>
+              <a:latin typeface="Calibri"/>
+            </a:endParaRPr>
+          </a:p>
+        </p:txBody>
+      </p:sp>
+      <p:sp>
+        <p:nvSpPr>
+          <p:cNvPr id="775" name="Rectangle 16"/>
+          <p:cNvSpPr/>
+          <p:nvPr/>
+        </p:nvSpPr>
+        <p:spPr>
+          <a:xfrm>
+            <a:off x="8001000" y="1508760"/>
+            <a:ext cx="3565800" cy="72720"/>
+          </a:xfrm>
+          <a:prstGeom prst="rect">
+            <a:avLst/>
+          </a:prstGeom>
+          <a:solidFill>
+            <a:srgbClr val="e8a838"/>
+          </a:solidFill>
+          <a:ln>
+            <a:noFill/>
+          </a:ln>
+          <a:effectLst>
+            <a:outerShdw blurRad="39960" dir="5400000" dist="23040" rotWithShape="0">
+              <a:srgbClr val="000000">
+                <a:alpha val="35000"/>
+              </a:srgbClr>
+            </a:outerShdw>
+          </a:effectLst>
+        </p:spPr>
+        <p:style>
+          <a:lnRef idx="1">
+            <a:schemeClr val="accent1"/>
+          </a:lnRef>
+          <a:fillRef idx="3">
+            <a:schemeClr val="accent1"/>
+          </a:fillRef>
+          <a:effectRef idx="2">
+            <a:schemeClr val="accent1"/>
+          </a:effectRef>
+          <a:fontRef idx="minor"/>
+        </p:style>
+        <p:txBody>
+          <a:bodyPr lIns="90000" rIns="90000" tIns="28080" bIns="28080" anchor="ctr">
+            <a:noAutofit/>
+          </a:bodyPr>
+          <a:p>
+            <a:pPr algn="ctr" defTabSz="457200">
+              <a:lnSpc>
+                <a:spcPct val="100000"/>
+              </a:lnSpc>
+            </a:pPr>
+            <a:endParaRPr b="0" lang="en-US" sz="1800" spc="-1" strike="noStrike">
+              <a:solidFill>
+                <a:schemeClr val="lt1"/>
+              </a:solidFill>
+              <a:latin typeface="Calibri"/>
+            </a:endParaRPr>
+          </a:p>
+        </p:txBody>
+      </p:sp>
+      <p:sp>
+        <p:nvSpPr>
+          <p:cNvPr id="776" name="TextBox 17"/>
+          <p:cNvSpPr/>
+          <p:nvPr/>
+        </p:nvSpPr>
+        <p:spPr>
+          <a:xfrm>
+            <a:off x="8138160" y="1645920"/>
+            <a:ext cx="3291480" cy="288000"/>
+          </a:xfrm>
+          <a:prstGeom prst="rect">
+            <a:avLst/>
+          </a:prstGeom>
+          <a:noFill/>
+          <a:ln w="0">
+            <a:noFill/>
+          </a:ln>
+        </p:spPr>
+        <p:style>
+          <a:lnRef idx="0"/>
+          <a:fillRef idx="0"/>
+          <a:effectRef idx="0"/>
+          <a:fontRef idx="minor"/>
+        </p:style>
+        <p:txBody>
+          <a:bodyPr lIns="90000" rIns="90000" tIns="45000" bIns="45000" anchor="t">
+            <a:spAutoFit/>
+          </a:bodyPr>
+          <a:p>
+            <a:pPr defTabSz="457200">
+              <a:lnSpc>
+                <a:spcPct val="100000"/>
+              </a:lnSpc>
+            </a:pPr>
+            <a:r>
+              <a:rPr b="1" lang="en-US" sz="1300" spc="-1" strike="noStrike">
+                <a:solidFill>
+                  <a:srgbClr val="e8a838"/>
+                </a:solidFill>
+                <a:latin typeface="Calibri"/>
+              </a:rPr>
+              <a:t>📊  </a:t>
+            </a:r>
+            <a:r>
+              <a:rPr b="1" lang="en-US" sz="1300" spc="-1" strike="noStrike">
+                <a:solidFill>
+                  <a:srgbClr val="e8a838"/>
+                </a:solidFill>
+                <a:latin typeface="Calibri"/>
+              </a:rPr>
+              <a:t>10%</a:t>
+            </a:r>
+            <a:endParaRPr b="0" lang="en-US" sz="1300" spc="-1" strike="noStrike">
+              <a:solidFill>
+                <a:srgbClr val="000000"/>
+              </a:solidFill>
+              <a:latin typeface="Arial"/>
+            </a:endParaRPr>
+          </a:p>
+        </p:txBody>
+      </p:sp>
+      <p:sp>
+        <p:nvSpPr>
+          <p:cNvPr id="777" name="TextBox 18"/>
+          <p:cNvSpPr/>
+          <p:nvPr/>
+        </p:nvSpPr>
+        <p:spPr>
+          <a:xfrm>
+            <a:off x="8138160" y="2020680"/>
+            <a:ext cx="3291480" cy="272520"/>
+          </a:xfrm>
+          <a:prstGeom prst="rect">
+            <a:avLst/>
+          </a:prstGeom>
+          <a:noFill/>
+          <a:ln w="0">
+            <a:noFill/>
+          </a:ln>
+        </p:spPr>
+        <p:style>
+          <a:lnRef idx="0"/>
+          <a:fillRef idx="0"/>
+          <a:effectRef idx="0"/>
+          <a:fontRef idx="minor"/>
+        </p:style>
+        <p:txBody>
+          <a:bodyPr lIns="90000" rIns="90000" tIns="45000" bIns="45000" anchor="t">
+            <a:spAutoFit/>
+          </a:bodyPr>
+          <a:p>
+            <a:pPr defTabSz="457200">
+              <a:lnSpc>
+                <a:spcPct val="100000"/>
+              </a:lnSpc>
+            </a:pPr>
+            <a:r>
+              <a:rPr b="1" lang="en-US" sz="1200" spc="-1" strike="noStrike">
+                <a:solidFill>
+                  <a:srgbClr val="ffffff"/>
+                </a:solidFill>
+                <a:latin typeface="Calibri"/>
+              </a:rPr>
+              <a:t>Аналитика и дашборд</a:t>
+            </a:r>
+            <a:endParaRPr b="0" lang="en-US" sz="1200" spc="-1" strike="noStrike">
+              <a:solidFill>
+                <a:srgbClr val="000000"/>
+              </a:solidFill>
+              <a:latin typeface="Arial"/>
+            </a:endParaRPr>
+          </a:p>
+        </p:txBody>
+      </p:sp>
+      <p:sp>
+        <p:nvSpPr>
+          <p:cNvPr id="778" name="TextBox 19"/>
+          <p:cNvSpPr/>
+          <p:nvPr/>
+        </p:nvSpPr>
+        <p:spPr>
+          <a:xfrm>
+            <a:off x="8138160" y="2386440"/>
+            <a:ext cx="3291480" cy="242280"/>
+          </a:xfrm>
+          <a:prstGeom prst="rect">
+            <a:avLst/>
+          </a:prstGeom>
+          <a:noFill/>
+          <a:ln w="0">
+            <a:noFill/>
+          </a:ln>
+        </p:spPr>
+        <p:style>
+          <a:lnRef idx="0"/>
+          <a:fillRef idx="0"/>
+          <a:effectRef idx="0"/>
+          <a:fontRef idx="minor"/>
+        </p:style>
+        <p:txBody>
+          <a:bodyPr lIns="90000" rIns="90000" tIns="45000" bIns="45000" anchor="t">
+            <a:spAutoFit/>
+          </a:bodyPr>
+          <a:p>
+            <a:pPr defTabSz="457200">
+              <a:lnSpc>
+                <a:spcPct val="100000"/>
+              </a:lnSpc>
+            </a:pPr>
+            <a:r>
+              <a:rPr b="0" lang="en-US" sz="1000" spc="-1" strike="noStrike">
+                <a:solidFill>
+                  <a:srgbClr val="aaccff"/>
+                </a:solidFill>
+                <a:latin typeface="Calibri"/>
+              </a:rPr>
+              <a:t>Dept quality · quarterly trend · maturity F-22 · radar chart</a:t>
+            </a:r>
+            <a:endParaRPr b="0" lang="en-US" sz="1000" spc="-1" strike="noStrike">
+              <a:solidFill>
+                <a:srgbClr val="000000"/>
+              </a:solidFill>
+              <a:latin typeface="Arial"/>
+            </a:endParaRPr>
+          </a:p>
+        </p:txBody>
+      </p:sp>
+      <p:sp>
+        <p:nvSpPr>
+          <p:cNvPr id="779" name="Rectangle 20"/>
+          <p:cNvSpPr/>
+          <p:nvPr/>
+        </p:nvSpPr>
+        <p:spPr>
+          <a:xfrm>
+            <a:off x="320040" y="3429000"/>
+            <a:ext cx="3565800" cy="1691280"/>
+          </a:xfrm>
+          <a:prstGeom prst="rect">
+            <a:avLst/>
+          </a:prstGeom>
+          <a:solidFill>
+            <a:srgbClr val="0d1b3e"/>
+          </a:solidFill>
+          <a:ln>
+            <a:noFill/>
+          </a:ln>
+          <a:effectLst>
+            <a:outerShdw blurRad="39960" dir="5400000" dist="23040" rotWithShape="0">
+              <a:srgbClr val="000000">
+                <a:alpha val="35000"/>
+              </a:srgbClr>
+            </a:outerShdw>
+          </a:effectLst>
+        </p:spPr>
+        <p:style>
+          <a:lnRef idx="1">
+            <a:schemeClr val="accent1"/>
+          </a:lnRef>
+          <a:fillRef idx="3">
+            <a:schemeClr val="accent1"/>
+          </a:fillRef>
+          <a:effectRef idx="2">
+            <a:schemeClr val="accent1"/>
+          </a:effectRef>
+          <a:fontRef idx="minor"/>
+        </p:style>
+        <p:txBody>
+          <a:bodyPr lIns="90000" rIns="90000" tIns="45000" bIns="45000" anchor="ctr">
+            <a:noAutofit/>
+          </a:bodyPr>
+          <a:p>
+            <a:pPr algn="ctr" defTabSz="457200">
+              <a:lnSpc>
+                <a:spcPct val="100000"/>
+              </a:lnSpc>
+            </a:pPr>
+            <a:endParaRPr b="0" lang="en-US" sz="1800" spc="-1" strike="noStrike">
+              <a:solidFill>
+                <a:schemeClr val="lt1"/>
+              </a:solidFill>
+              <a:latin typeface="Calibri"/>
+            </a:endParaRPr>
+          </a:p>
+        </p:txBody>
+      </p:sp>
+      <p:sp>
+        <p:nvSpPr>
+          <p:cNvPr id="780" name="Rectangle 21"/>
+          <p:cNvSpPr/>
+          <p:nvPr/>
+        </p:nvSpPr>
+        <p:spPr>
+          <a:xfrm>
+            <a:off x="320040" y="3429000"/>
+            <a:ext cx="3565800" cy="72720"/>
+          </a:xfrm>
+          <a:prstGeom prst="rect">
+            <a:avLst/>
+          </a:prstGeom>
+          <a:solidFill>
+            <a:srgbClr val="e8a838"/>
+          </a:solidFill>
+          <a:ln>
+            <a:noFill/>
+          </a:ln>
+          <a:effectLst>
+            <a:outerShdw blurRad="39960" dir="5400000" dist="23040" rotWithShape="0">
+              <a:srgbClr val="000000">
+                <a:alpha val="35000"/>
+              </a:srgbClr>
+            </a:outerShdw>
+          </a:effectLst>
+        </p:spPr>
+        <p:style>
+          <a:lnRef idx="1">
+            <a:schemeClr val="accent1"/>
+          </a:lnRef>
+          <a:fillRef idx="3">
+            <a:schemeClr val="accent1"/>
+          </a:fillRef>
+          <a:effectRef idx="2">
+            <a:schemeClr val="accent1"/>
+          </a:effectRef>
+          <a:fontRef idx="minor"/>
+        </p:style>
+        <p:txBody>
+          <a:bodyPr lIns="90000" rIns="90000" tIns="28080" bIns="28080" anchor="ctr">
+            <a:noAutofit/>
+          </a:bodyPr>
+          <a:p>
+            <a:pPr algn="ctr" defTabSz="457200">
+              <a:lnSpc>
+                <a:spcPct val="100000"/>
+              </a:lnSpc>
+            </a:pPr>
+            <a:endParaRPr b="0" lang="en-US" sz="1800" spc="-1" strike="noStrike">
+              <a:solidFill>
+                <a:schemeClr val="lt1"/>
+              </a:solidFill>
+              <a:latin typeface="Calibri"/>
+            </a:endParaRPr>
+          </a:p>
+        </p:txBody>
+      </p:sp>
+      <p:sp>
+        <p:nvSpPr>
+          <p:cNvPr id="781" name="TextBox 22"/>
+          <p:cNvSpPr/>
+          <p:nvPr/>
+        </p:nvSpPr>
+        <p:spPr>
+          <a:xfrm>
+            <a:off x="457200" y="3566160"/>
+            <a:ext cx="3291480" cy="288000"/>
+          </a:xfrm>
+          <a:prstGeom prst="rect">
+            <a:avLst/>
+          </a:prstGeom>
+          <a:noFill/>
+          <a:ln w="0">
+            <a:noFill/>
+          </a:ln>
+        </p:spPr>
+        <p:style>
+          <a:lnRef idx="0"/>
+          <a:fillRef idx="0"/>
+          <a:effectRef idx="0"/>
+          <a:fontRef idx="minor"/>
+        </p:style>
+        <p:txBody>
+          <a:bodyPr lIns="90000" rIns="90000" tIns="45000" bIns="45000" anchor="t">
+            <a:spAutoFit/>
+          </a:bodyPr>
+          <a:p>
+            <a:pPr defTabSz="457200">
+              <a:lnSpc>
+                <a:spcPct val="100000"/>
+              </a:lnSpc>
+            </a:pPr>
+            <a:r>
+              <a:rPr b="1" lang="en-US" sz="1300" spc="-1" strike="noStrike">
+                <a:solidFill>
+                  <a:srgbClr val="e8a838"/>
+                </a:solidFill>
+                <a:latin typeface="Calibri"/>
+              </a:rPr>
+              <a:t>⚙️  </a:t>
+            </a:r>
+            <a:r>
+              <a:rPr b="1" lang="en-US" sz="1300" spc="-1" strike="noStrike">
+                <a:solidFill>
+                  <a:srgbClr val="e8a838"/>
+                </a:solidFill>
+                <a:latin typeface="Calibri"/>
+              </a:rPr>
+              <a:t>10%</a:t>
+            </a:r>
+            <a:endParaRPr b="0" lang="en-US" sz="1300" spc="-1" strike="noStrike">
+              <a:solidFill>
+                <a:srgbClr val="000000"/>
+              </a:solidFill>
+              <a:latin typeface="Arial"/>
+            </a:endParaRPr>
+          </a:p>
+        </p:txBody>
+      </p:sp>
+      <p:sp>
+        <p:nvSpPr>
+          <p:cNvPr id="782" name="TextBox 23"/>
+          <p:cNvSpPr/>
+          <p:nvPr/>
+        </p:nvSpPr>
+        <p:spPr>
+          <a:xfrm>
+            <a:off x="457200" y="3940920"/>
+            <a:ext cx="3291480" cy="272520"/>
+          </a:xfrm>
+          <a:prstGeom prst="rect">
+            <a:avLst/>
+          </a:prstGeom>
+          <a:noFill/>
+          <a:ln w="0">
+            <a:noFill/>
+          </a:ln>
+        </p:spPr>
+        <p:style>
+          <a:lnRef idx="0"/>
+          <a:fillRef idx="0"/>
+          <a:effectRef idx="0"/>
+          <a:fontRef idx="minor"/>
+        </p:style>
+        <p:txBody>
+          <a:bodyPr lIns="90000" rIns="90000" tIns="45000" bIns="45000" anchor="t">
+            <a:spAutoFit/>
+          </a:bodyPr>
+          <a:p>
+            <a:pPr defTabSz="457200">
+              <a:lnSpc>
+                <a:spcPct val="100000"/>
+              </a:lnSpc>
+            </a:pPr>
+            <a:r>
+              <a:rPr b="1" lang="en-US" sz="1200" spc="-1" strike="noStrike">
+                <a:solidFill>
+                  <a:srgbClr val="ffffff"/>
+                </a:solidFill>
+                <a:latin typeface="Calibri"/>
+              </a:rPr>
+              <a:t>Архитектура и API</a:t>
+            </a:r>
+            <a:endParaRPr b="0" lang="en-US" sz="1200" spc="-1" strike="noStrike">
+              <a:solidFill>
+                <a:srgbClr val="000000"/>
+              </a:solidFill>
+              <a:latin typeface="Arial"/>
+            </a:endParaRPr>
+          </a:p>
+        </p:txBody>
+      </p:sp>
+      <p:sp>
+        <p:nvSpPr>
+          <p:cNvPr id="783" name="TextBox 24"/>
+          <p:cNvSpPr/>
+          <p:nvPr/>
+        </p:nvSpPr>
+        <p:spPr>
+          <a:xfrm>
+            <a:off x="457200" y="4306680"/>
+            <a:ext cx="3291480" cy="394920"/>
+          </a:xfrm>
+          <a:prstGeom prst="rect">
+            <a:avLst/>
+          </a:prstGeom>
+          <a:noFill/>
+          <a:ln w="0">
+            <a:noFill/>
+          </a:ln>
+        </p:spPr>
+        <p:style>
+          <a:lnRef idx="0"/>
+          <a:fillRef idx="0"/>
+          <a:effectRef idx="0"/>
+          <a:fontRef idx="minor"/>
+        </p:style>
+        <p:txBody>
+          <a:bodyPr lIns="90000" rIns="90000" tIns="45000" bIns="45000" anchor="t">
+            <a:spAutoFit/>
+          </a:bodyPr>
+          <a:p>
+            <a:pPr defTabSz="457200">
+              <a:lnSpc>
+                <a:spcPct val="100000"/>
+              </a:lnSpc>
+            </a:pPr>
+            <a:r>
+              <a:rPr b="0" lang="en-US" sz="1000" spc="-1" strike="noStrike">
+                <a:solidFill>
+                  <a:srgbClr val="aaccff"/>
+                </a:solidFill>
+                <a:latin typeface="Calibri"/>
+              </a:rPr>
+              <a:t>FastAPI · OpenAPI /docs · Docker Compose · Alembic · Pydantic v2</a:t>
+            </a:r>
+            <a:endParaRPr b="0" lang="en-US" sz="1000" spc="-1" strike="noStrike">
+              <a:solidFill>
+                <a:srgbClr val="000000"/>
+              </a:solidFill>
+              <a:latin typeface="Arial"/>
+            </a:endParaRPr>
+          </a:p>
+        </p:txBody>
+      </p:sp>
+      <p:sp>
+        <p:nvSpPr>
+          <p:cNvPr id="784" name="Rectangle 25"/>
+          <p:cNvSpPr/>
+          <p:nvPr/>
+        </p:nvSpPr>
+        <p:spPr>
+          <a:xfrm>
+            <a:off x="4160520" y="3429000"/>
+            <a:ext cx="3565800" cy="1691280"/>
+          </a:xfrm>
+          <a:prstGeom prst="rect">
+            <a:avLst/>
+          </a:prstGeom>
+          <a:solidFill>
+            <a:srgbClr val="0d1b3e"/>
+          </a:solidFill>
+          <a:ln>
+            <a:noFill/>
+          </a:ln>
+          <a:effectLst>
+            <a:outerShdw blurRad="39960" dir="5400000" dist="23040" rotWithShape="0">
+              <a:srgbClr val="000000">
+                <a:alpha val="35000"/>
+              </a:srgbClr>
+            </a:outerShdw>
+          </a:effectLst>
+        </p:spPr>
+        <p:style>
+          <a:lnRef idx="1">
+            <a:schemeClr val="accent1"/>
+          </a:lnRef>
+          <a:fillRef idx="3">
+            <a:schemeClr val="accent1"/>
+          </a:fillRef>
+          <a:effectRef idx="2">
+            <a:schemeClr val="accent1"/>
+          </a:effectRef>
+          <a:fontRef idx="minor"/>
+        </p:style>
+        <p:txBody>
+          <a:bodyPr lIns="90000" rIns="90000" tIns="45000" bIns="45000" anchor="ctr">
+            <a:noAutofit/>
+          </a:bodyPr>
+          <a:p>
+            <a:pPr algn="ctr" defTabSz="457200">
+              <a:lnSpc>
+                <a:spcPct val="100000"/>
+              </a:lnSpc>
+            </a:pPr>
+            <a:endParaRPr b="0" lang="en-US" sz="1800" spc="-1" strike="noStrike">
+              <a:solidFill>
+                <a:schemeClr val="lt1"/>
+              </a:solidFill>
+              <a:latin typeface="Calibri"/>
+            </a:endParaRPr>
+          </a:p>
+        </p:txBody>
+      </p:sp>
+      <p:sp>
+        <p:nvSpPr>
+          <p:cNvPr id="785" name="Rectangle 26"/>
+          <p:cNvSpPr/>
+          <p:nvPr/>
+        </p:nvSpPr>
+        <p:spPr>
+          <a:xfrm>
+            <a:off x="4160520" y="3429000"/>
+            <a:ext cx="3565800" cy="72720"/>
+          </a:xfrm>
+          <a:prstGeom prst="rect">
+            <a:avLst/>
+          </a:prstGeom>
+          <a:solidFill>
+            <a:srgbClr val="e8a838"/>
+          </a:solidFill>
+          <a:ln>
+            <a:noFill/>
+          </a:ln>
+          <a:effectLst>
+            <a:outerShdw blurRad="39960" dir="5400000" dist="23040" rotWithShape="0">
+              <a:srgbClr val="000000">
+                <a:alpha val="35000"/>
+              </a:srgbClr>
+            </a:outerShdw>
+          </a:effectLst>
+        </p:spPr>
+        <p:style>
+          <a:lnRef idx="1">
+            <a:schemeClr val="accent1"/>
+          </a:lnRef>
+          <a:fillRef idx="3">
+            <a:schemeClr val="accent1"/>
+          </a:fillRef>
+          <a:effectRef idx="2">
+            <a:schemeClr val="accent1"/>
+          </a:effectRef>
+          <a:fontRef idx="minor"/>
+        </p:style>
+        <p:txBody>
+          <a:bodyPr lIns="90000" rIns="90000" tIns="28080" bIns="28080" anchor="ctr">
+            <a:noAutofit/>
+          </a:bodyPr>
+          <a:p>
+            <a:pPr algn="ctr" defTabSz="457200">
+              <a:lnSpc>
+                <a:spcPct val="100000"/>
+              </a:lnSpc>
+            </a:pPr>
+            <a:endParaRPr b="0" lang="en-US" sz="1800" spc="-1" strike="noStrike">
+              <a:solidFill>
+                <a:schemeClr val="lt1"/>
+              </a:solidFill>
+              <a:latin typeface="Calibri"/>
+            </a:endParaRPr>
+          </a:p>
+        </p:txBody>
+      </p:sp>
+      <p:sp>
+        <p:nvSpPr>
+          <p:cNvPr id="786" name="TextBox 27"/>
+          <p:cNvSpPr/>
+          <p:nvPr/>
+        </p:nvSpPr>
+        <p:spPr>
+          <a:xfrm>
+            <a:off x="4297680" y="3566160"/>
+            <a:ext cx="3291480" cy="288000"/>
+          </a:xfrm>
+          <a:prstGeom prst="rect">
+            <a:avLst/>
+          </a:prstGeom>
+          <a:noFill/>
+          <a:ln w="0">
+            <a:noFill/>
+          </a:ln>
+        </p:spPr>
+        <p:style>
+          <a:lnRef idx="0"/>
+          <a:fillRef idx="0"/>
+          <a:effectRef idx="0"/>
+          <a:fontRef idx="minor"/>
+        </p:style>
+        <p:txBody>
+          <a:bodyPr lIns="90000" rIns="90000" tIns="45000" bIns="45000" anchor="t">
+            <a:spAutoFit/>
+          </a:bodyPr>
+          <a:p>
+            <a:pPr defTabSz="457200">
+              <a:lnSpc>
+                <a:spcPct val="100000"/>
+              </a:lnSpc>
+            </a:pPr>
+            <a:r>
+              <a:rPr b="1" lang="en-US" sz="1300" spc="-1" strike="noStrike">
+                <a:solidFill>
+                  <a:srgbClr val="e8a838"/>
+                </a:solidFill>
+                <a:latin typeface="Calibri"/>
+              </a:rPr>
+              <a:t>💻  </a:t>
+            </a:r>
+            <a:r>
+              <a:rPr b="1" lang="en-US" sz="1300" spc="-1" strike="noStrike">
+                <a:solidFill>
+                  <a:srgbClr val="e8a838"/>
+                </a:solidFill>
+                <a:latin typeface="Calibri"/>
+              </a:rPr>
+              <a:t>15%</a:t>
+            </a:r>
+            <a:endParaRPr b="0" lang="en-US" sz="1300" spc="-1" strike="noStrike">
+              <a:solidFill>
+                <a:srgbClr val="000000"/>
+              </a:solidFill>
+              <a:latin typeface="Arial"/>
+            </a:endParaRPr>
+          </a:p>
+        </p:txBody>
+      </p:sp>
+      <p:sp>
+        <p:nvSpPr>
+          <p:cNvPr id="787" name="TextBox 28"/>
+          <p:cNvSpPr/>
+          <p:nvPr/>
+        </p:nvSpPr>
+        <p:spPr>
+          <a:xfrm>
+            <a:off x="4297680" y="3940920"/>
+            <a:ext cx="3291480" cy="272520"/>
+          </a:xfrm>
+          <a:prstGeom prst="rect">
+            <a:avLst/>
+          </a:prstGeom>
+          <a:noFill/>
+          <a:ln w="0">
+            <a:noFill/>
+          </a:ln>
+        </p:spPr>
+        <p:style>
+          <a:lnRef idx="0"/>
+          <a:fillRef idx="0"/>
+          <a:effectRef idx="0"/>
+          <a:fontRef idx="minor"/>
+        </p:style>
+        <p:txBody>
+          <a:bodyPr lIns="90000" rIns="90000" tIns="45000" bIns="45000" anchor="t">
+            <a:spAutoFit/>
+          </a:bodyPr>
+          <a:p>
+            <a:pPr defTabSz="457200">
+              <a:lnSpc>
+                <a:spcPct val="100000"/>
+              </a:lnSpc>
+            </a:pPr>
+            <a:r>
+              <a:rPr b="1" lang="en-US" sz="1200" spc="-1" strike="noStrike">
+                <a:solidFill>
+                  <a:srgbClr val="ffffff"/>
+                </a:solidFill>
+                <a:latin typeface="Calibri"/>
+              </a:rPr>
+              <a:t>UX интерфейса</a:t>
+            </a:r>
+            <a:endParaRPr b="0" lang="en-US" sz="1200" spc="-1" strike="noStrike">
+              <a:solidFill>
+                <a:srgbClr val="000000"/>
+              </a:solidFill>
+              <a:latin typeface="Arial"/>
+            </a:endParaRPr>
+          </a:p>
+        </p:txBody>
+      </p:sp>
+      <p:sp>
+        <p:nvSpPr>
+          <p:cNvPr id="788" name="TextBox 29"/>
+          <p:cNvSpPr/>
+          <p:nvPr/>
+        </p:nvSpPr>
+        <p:spPr>
+          <a:xfrm>
+            <a:off x="4297680" y="4306680"/>
+            <a:ext cx="3291480" cy="242280"/>
+          </a:xfrm>
+          <a:prstGeom prst="rect">
+            <a:avLst/>
+          </a:prstGeom>
+          <a:noFill/>
+          <a:ln w="0">
+            <a:noFill/>
+          </a:ln>
+        </p:spPr>
+        <p:style>
+          <a:lnRef idx="0"/>
+          <a:fillRef idx="0"/>
+          <a:effectRef idx="0"/>
+          <a:fontRef idx="minor"/>
+        </p:style>
+        <p:txBody>
+          <a:bodyPr lIns="90000" rIns="90000" tIns="45000" bIns="45000" anchor="t">
+            <a:spAutoFit/>
+          </a:bodyPr>
+          <a:p>
+            <a:pPr defTabSz="457200">
+              <a:lnSpc>
+                <a:spcPct val="100000"/>
+              </a:lnSpc>
+            </a:pPr>
+            <a:r>
+              <a:rPr b="0" lang="en-US" sz="1000" spc="-1" strike="noStrike">
+                <a:solidFill>
+                  <a:srgbClr val="aaccff"/>
+                </a:solidFill>
+                <a:latin typeface="Calibri"/>
+              </a:rPr>
+              <a:t>React 18 · MUI · 6 страниц · progress bars · alert banners</a:t>
+            </a:r>
+            <a:endParaRPr b="0" lang="en-US" sz="1000" spc="-1" strike="noStrike">
+              <a:solidFill>
+                <a:srgbClr val="000000"/>
+              </a:solidFill>
+              <a:latin typeface="Arial"/>
+            </a:endParaRPr>
+          </a:p>
+        </p:txBody>
+      </p:sp>
+      <p:sp>
+        <p:nvSpPr>
+          <p:cNvPr id="789" name="TextBox 30"/>
+          <p:cNvSpPr/>
+          <p:nvPr/>
+        </p:nvSpPr>
+        <p:spPr>
+          <a:xfrm>
+            <a:off x="457200" y="6309360"/>
+            <a:ext cx="11274120" cy="272520"/>
+          </a:xfrm>
+          <a:prstGeom prst="rect">
+            <a:avLst/>
+          </a:prstGeom>
+          <a:noFill/>
+          <a:ln w="0">
+            <a:noFill/>
+          </a:ln>
+        </p:spPr>
+        <p:style>
+          <a:lnRef idx="0"/>
+          <a:fillRef idx="0"/>
+          <a:effectRef idx="0"/>
+          <a:fontRef idx="minor"/>
+        </p:style>
+        <p:txBody>
+          <a:bodyPr lIns="90000" rIns="90000" tIns="45000" bIns="45000" anchor="t">
+            <a:spAutoFit/>
+          </a:bodyPr>
+          <a:p>
+            <a:pPr algn="ctr" defTabSz="457200">
+              <a:lnSpc>
+                <a:spcPct val="100000"/>
+              </a:lnSpc>
+            </a:pPr>
+            <a:r>
+              <a:rPr b="0" i="1" lang="en-US" sz="1200" spc="-1" strike="noStrike">
+                <a:solidFill>
+                  <a:srgbClr val="99bbee"/>
+                </a:solidFill>
+                <a:latin typeface="Calibri"/>
+              </a:rPr>
+              <a:t>Frontend: http://89.207.255.254:3000   ·   API: http://89.207.255.254:8001/docs</a:t>
+            </a:r>
+            <a:endParaRPr b="0" lang="en-US" sz="1200" spc="-1" strike="noStrike">
+              <a:solidFill>
+                <a:srgbClr val="000000"/>
+              </a:solidFill>
+              <a:latin typeface="Arial"/>
+            </a:endParaRPr>
+          </a:p>
+        </p:txBody>
+      </p:sp>
+      <p:sp>
+        <p:nvSpPr>
+          <p:cNvPr id="790" name="TextBox 31"/>
+          <p:cNvSpPr/>
+          <p:nvPr/>
+        </p:nvSpPr>
+        <p:spPr>
+          <a:xfrm>
+            <a:off x="11064240" y="6492240"/>
+            <a:ext cx="1005480" cy="242280"/>
+          </a:xfrm>
+          <a:prstGeom prst="rect">
+            <a:avLst/>
+          </a:prstGeom>
+          <a:noFill/>
+          <a:ln w="0">
+            <a:noFill/>
+          </a:ln>
+        </p:spPr>
+        <p:style>
+          <a:lnRef idx="0"/>
+          <a:fillRef idx="0"/>
+          <a:effectRef idx="0"/>
+          <a:fontRef idx="minor"/>
+        </p:style>
+        <p:txBody>
+          <a:bodyPr lIns="90000" rIns="90000" tIns="45000" bIns="45000" anchor="t">
+            <a:spAutoFit/>
+          </a:bodyPr>
+          <a:p>
             <a:pPr algn="r" defTabSz="457200">
               <a:lnSpc>
                 <a:spcPct val="100000"/>
@@ -35274,7 +37299,7 @@
                 </a:solidFill>
                 <a:latin typeface="Calibri"/>
               </a:rPr>
-              <a:t>20 / 20</a:t>
+              <a:t>21 / 21</a:t>
             </a:r>
             <a:endParaRPr b="0" lang="en-US" sz="1000" spc="-1" strike="noStrike">
               <a:solidFill>
@@ -37105,7 +39130,7 @@
                 </a:solidFill>
                 <a:latin typeface="Calibri"/>
               </a:rPr>
-              <a:t>3 / 20</a:t>
+              <a:t>3 / 21</a:t>
             </a:r>
             <a:endParaRPr b="0" lang="en-US" sz="1000" spc="-1" strike="noStrike">
               <a:solidFill>
@@ -39347,7 +41372,7 @@
                 </a:solidFill>
                 <a:latin typeface="Calibri"/>
               </a:rPr>
-              <a:t>4 / 20</a:t>
+              <a:t>4 / 21</a:t>
             </a:r>
             <a:endParaRPr b="0" lang="en-US" sz="1000" spc="-1" strike="noStrike">
               <a:solidFill>
@@ -42735,7 +44760,7 @@
                 </a:solidFill>
                 <a:latin typeface="Calibri"/>
               </a:rPr>
-              <a:t>5 / 20</a:t>
+              <a:t>5 / 21</a:t>
             </a:r>
             <a:endParaRPr b="0" lang="en-US" sz="1000" spc="-1" strike="noStrike">
               <a:solidFill>
@@ -44865,7 +46890,7 @@
                 </a:solidFill>
                 <a:latin typeface="Calibri"/>
               </a:rPr>
-              <a:t>6 / 20</a:t>
+              <a:t>6 / 21</a:t>
             </a:r>
             <a:endParaRPr b="0" lang="en-US" sz="1000" spc="-1" strike="noStrike">
               <a:solidFill>
@@ -45301,7 +47326,7 @@
                 </a:solidFill>
                 <a:latin typeface="Calibri"/>
               </a:rPr>
-              <a:t>7 / 20</a:t>
+              <a:t>7 / 21</a:t>
             </a:r>
             <a:endParaRPr b="0" lang="en-US" sz="1000" spc="-1" strike="noStrike">
               <a:solidFill>
@@ -46482,7 +48507,7 @@
                 </a:solidFill>
                 <a:latin typeface="Calibri"/>
               </a:rPr>
-              <a:t>8 / 20</a:t>
+              <a:t>8 / 21</a:t>
             </a:r>
             <a:endParaRPr b="0" lang="en-US" sz="1000" spc="-1" strike="noStrike">
               <a:solidFill>
@@ -47663,7 +49688,7 @@
                 </a:solidFill>
                 <a:latin typeface="Calibri"/>
               </a:rPr>
-              <a:t>9 / 20</a:t>
+              <a:t>9 / 21</a:t>
             </a:r>
             <a:endParaRPr b="0" lang="en-US" sz="1000" spc="-1" strike="noStrike">
               <a:solidFill>

</xml_diff>